<commit_message>
docs: align AAT report and presentation templates
</commit_message>
<xml_diff>
--- a/reports/Privacy_Preserving_Financial_NER_Presentation.pptx
+++ b/reports/Privacy_Preserving_Financial_NER_Presentation.pptx
@@ -13,6 +13,11 @@
     <p:sldId id="262" r:id="rId7"/>
     <p:sldId id="263" r:id="rId8"/>
     <p:sldId id="264" r:id="rId9"/>
+    <p:sldId id="265" r:id="rId10"/>
+    <p:sldId id="266" r:id="rId11"/>
+    <p:sldId id="267" r:id="rId12"/>
+    <p:sldId id="268" r:id="rId13"/>
+    <p:sldId id="269" r:id="rId14"/>
   </p:sldIdLst>
   <p:sldSz cx="12192000" cy="6858000"/>
   <p:notesSz cx="6858000" cy="9144000"/>
@@ -95,14 +100,546 @@
         </p:nvSpPr>
         <p:spPr>
           <a:xfrm>
-            <a:off x="720000" y="480000"/>
+            <a:off x="500000" y="350000"/>
+            <a:ext cx="11600000" cy="420000"/>
+          </a:xfrm>
+          <a:prstGeom prst="rect">
+            <a:avLst/>
+          </a:prstGeom>
+          <a:solidFill>
+            <a:srgbClr val="FFFFFF"/>
+          </a:solidFill>
+          <a:ln>
+            <a:noFill/>
+          </a:ln>
+        </p:spPr>
+        <p:txBody>
+          <a:bodyPr wrap="square"/>
+          <a:lstStyle/>
+          <a:p>
+            <a:pPr marL="0" algn="l"/>
+            <a:r>
+              <a:r>
+                <a:rPr lang="en-US" sz="2850">
+                  <a:b/>
+                  <a:solidFill>
+                    <a:srgbClr val="1A1A1A"/>
+                  </a:solidFill>
+                </a:rPr>
+                <a:t>B.M.S. COLLEGE OF ENGINEERING</a:t>
+              </a:r>
+            </a:r>
+            <a:endParaRPr lang="en-US" sz="2850"/>
+          </a:p>
+        </p:txBody>
+      </p:sp>
+      <p:sp>
+        <p:nvSpPr>
+          <p:cNvPr id="3" name="TextBox 3"/>
+          <p:cNvSpPr/>
+          <p:nvPr/>
+        </p:nvSpPr>
+        <p:spPr>
+          <a:xfrm>
+            <a:off x="500000" y="780000"/>
+            <a:ext cx="11600000" cy="300000"/>
+          </a:xfrm>
+          <a:prstGeom prst="rect">
+            <a:avLst/>
+          </a:prstGeom>
+          <a:solidFill>
+            <a:srgbClr val="FFFFFF"/>
+          </a:solidFill>
+          <a:ln>
+            <a:noFill/>
+          </a:ln>
+        </p:spPr>
+        <p:txBody>
+          <a:bodyPr wrap="square"/>
+          <a:lstStyle/>
+          <a:p>
+            <a:pPr marL="0" algn="l"/>
+            <a:r>
+              <a:r>
+                <a:rPr lang="en-US" sz="1250">
+                  <a:solidFill>
+                    <a:srgbClr val="1A1A1A"/>
+                  </a:solidFill>
+                </a:rPr>
+                <a:t>(Autonomous Institute, Affiliated to VTU, Belagavi)</a:t>
+              </a:r>
+            </a:r>
+            <a:endParaRPr lang="en-US" sz="1250"/>
+          </a:p>
+        </p:txBody>
+      </p:sp>
+      <p:sp>
+        <p:nvSpPr>
+          <p:cNvPr id="4" name="TextBox 4"/>
+          <p:cNvSpPr/>
+          <p:nvPr/>
+        </p:nvSpPr>
+        <p:spPr>
+          <a:xfrm>
+            <a:off x="500000" y="1180000"/>
+            <a:ext cx="11600000" cy="500000"/>
+          </a:xfrm>
+          <a:prstGeom prst="rect">
+            <a:avLst/>
+          </a:prstGeom>
+          <a:solidFill>
+            <a:srgbClr val="FFFFFF"/>
+          </a:solidFill>
+          <a:ln>
+            <a:noFill/>
+          </a:ln>
+        </p:spPr>
+        <p:txBody>
+          <a:bodyPr wrap="square"/>
+          <a:lstStyle/>
+          <a:p>
+            <a:pPr marL="0" algn="l"/>
+            <a:r>
+              <a:r>
+                <a:rPr lang="en-US" sz="2650">
+                  <a:b/>
+                  <a:solidFill>
+                    <a:srgbClr val="0000CC"/>
+                  </a:solidFill>
+                </a:rPr>
+                <a:t>DEPARTMENT OF MACHINE LEARNING</a:t>
+              </a:r>
+            </a:r>
+            <a:endParaRPr lang="en-US" sz="2650"/>
+          </a:p>
+        </p:txBody>
+      </p:sp>
+      <p:sp>
+        <p:nvSpPr>
+          <p:cNvPr id="5" name="TextBox 5"/>
+          <p:cNvSpPr/>
+          <p:nvPr/>
+        </p:nvSpPr>
+        <p:spPr>
+          <a:xfrm>
+            <a:off x="500000" y="1740000"/>
+            <a:ext cx="11600000" cy="370000"/>
+          </a:xfrm>
+          <a:prstGeom prst="rect">
+            <a:avLst/>
+          </a:prstGeom>
+          <a:solidFill>
+            <a:srgbClr val="FFFFFF"/>
+          </a:solidFill>
+          <a:ln>
+            <a:noFill/>
+          </a:ln>
+        </p:spPr>
+        <p:txBody>
+          <a:bodyPr wrap="square"/>
+          <a:lstStyle/>
+          <a:p>
+            <a:pPr marL="0" algn="l"/>
+            <a:r>
+              <a:r>
+                <a:rPr lang="en-US" sz="1350">
+                  <a:solidFill>
+                    <a:srgbClr val="0000CC"/>
+                  </a:solidFill>
+                </a:rPr>
+                <a:t>(UG Program: B.E. in Artificial Intelligence and Machine Learning)</a:t>
+              </a:r>
+            </a:r>
+            <a:endParaRPr lang="en-US" sz="1350"/>
+          </a:p>
+        </p:txBody>
+      </p:sp>
+      <p:sp>
+        <p:nvSpPr>
+          <p:cNvPr id="6" name="TextBox 6"/>
+          <p:cNvSpPr/>
+          <p:nvPr/>
+        </p:nvSpPr>
+        <p:spPr>
+          <a:xfrm>
+            <a:off x="500000" y="2450000"/>
+            <a:ext cx="11600000" cy="450000"/>
+          </a:xfrm>
+          <a:prstGeom prst="rect">
+            <a:avLst/>
+          </a:prstGeom>
+          <a:solidFill>
+            <a:srgbClr val="FFFFFF"/>
+          </a:solidFill>
+          <a:ln>
+            <a:noFill/>
+          </a:ln>
+        </p:spPr>
+        <p:txBody>
+          <a:bodyPr wrap="square"/>
+          <a:lstStyle/>
+          <a:p>
+            <a:pPr marL="0" algn="l"/>
+            <a:r>
+              <a:r>
+                <a:rPr lang="en-US" sz="2050">
+                  <a:b/>
+                  <a:solidFill>
+                    <a:srgbClr val="6B3E25"/>
+                  </a:solidFill>
+                </a:rPr>
+                <a:t>Course: Natural Language Processing for LLM</a:t>
+              </a:r>
+            </a:r>
+            <a:endParaRPr lang="en-US" sz="2050"/>
+          </a:p>
+          <a:p>
+            <a:pPr marL="0" algn="l"/>
+            <a:r>
+              <a:r>
+                <a:rPr lang="en-US" sz="2050">
+                  <a:b/>
+                  <a:solidFill>
+                    <a:srgbClr val="6B3E25"/>
+                  </a:solidFill>
+                </a:rPr>
+                <a:t>Course Code: 24AM7PCLLM</a:t>
+              </a:r>
+            </a:r>
+            <a:endParaRPr lang="en-US" sz="2050"/>
+          </a:p>
+        </p:txBody>
+      </p:sp>
+      <p:sp>
+        <p:nvSpPr>
+          <p:cNvPr id="7" name="TextBox 7"/>
+          <p:cNvSpPr/>
+          <p:nvPr/>
+        </p:nvSpPr>
+        <p:spPr>
+          <a:xfrm>
+            <a:off x="500000" y="3300000"/>
+            <a:ext cx="11600000" cy="500000"/>
+          </a:xfrm>
+          <a:prstGeom prst="rect">
+            <a:avLst/>
+          </a:prstGeom>
+          <a:solidFill>
+            <a:srgbClr val="FFFFFF"/>
+          </a:solidFill>
+          <a:ln>
+            <a:noFill/>
+          </a:ln>
+        </p:spPr>
+        <p:txBody>
+          <a:bodyPr wrap="square"/>
+          <a:lstStyle/>
+          <a:p>
+            <a:pPr marL="0" algn="l"/>
+            <a:r>
+              <a:r>
+                <a:rPr lang="en-US" sz="2200">
+                  <a:b/>
+                  <a:solidFill>
+                    <a:srgbClr val="0000CC"/>
+                  </a:solidFill>
+                </a:rPr>
+                <a:t>PRIVACY-PRESERVING NAMED ENTITY RECOGNITION</a:t>
+              </a:r>
+            </a:r>
+            <a:endParaRPr lang="en-US" sz="2200"/>
+          </a:p>
+          <a:p>
+            <a:pPr marL="0" algn="l"/>
+            <a:r>
+              <a:r>
+                <a:rPr lang="en-US" sz="2200">
+                  <a:b/>
+                  <a:solidFill>
+                    <a:srgbClr val="0000CC"/>
+                  </a:solidFill>
+                </a:rPr>
+                <a:t>FOR AUTOMATED PCI/PII DETECTION IN FINANCIAL TEXT</a:t>
+              </a:r>
+            </a:r>
+            <a:endParaRPr lang="en-US" sz="2200"/>
+          </a:p>
+        </p:txBody>
+      </p:sp>
+      <p:sp>
+        <p:nvSpPr>
+          <p:cNvPr id="8" name="TextBox 8"/>
+          <p:cNvSpPr/>
+          <p:nvPr/>
+        </p:nvSpPr>
+        <p:spPr>
+          <a:xfrm>
+            <a:off x="500000" y="4050000"/>
+            <a:ext cx="11600000" cy="370000"/>
+          </a:xfrm>
+          <a:prstGeom prst="rect">
+            <a:avLst/>
+          </a:prstGeom>
+          <a:solidFill>
+            <a:srgbClr val="FFFFFF"/>
+          </a:solidFill>
+          <a:ln>
+            <a:noFill/>
+          </a:ln>
+        </p:spPr>
+        <p:txBody>
+          <a:bodyPr wrap="square"/>
+          <a:lstStyle/>
+          <a:p>
+            <a:pPr marL="0" algn="l"/>
+            <a:r>
+              <a:r>
+                <a:rPr lang="en-US" sz="1550">
+                  <a:b/>
+                  <a:solidFill>
+                    <a:srgbClr val="A52A74"/>
+                  </a:solidFill>
+                </a:rPr>
+                <a:t>Alternative Assessment Tool (AAT)</a:t>
+              </a:r>
+            </a:r>
+            <a:endParaRPr lang="en-US" sz="1550"/>
+          </a:p>
+        </p:txBody>
+      </p:sp>
+      <p:sp>
+        <p:nvSpPr>
+          <p:cNvPr id="9" name="TextBox 9"/>
+          <p:cNvSpPr/>
+          <p:nvPr/>
+        </p:nvSpPr>
+        <p:spPr>
+          <a:xfrm>
+            <a:off x="500000" y="5050000"/>
+            <a:ext cx="5300000" cy="900000"/>
+          </a:xfrm>
+          <a:prstGeom prst="rect">
+            <a:avLst/>
+          </a:prstGeom>
+          <a:solidFill>
+            <a:srgbClr val="FFFFFF"/>
+          </a:solidFill>
+          <a:ln>
+            <a:noFill/>
+          </a:ln>
+        </p:spPr>
+        <p:txBody>
+          <a:bodyPr wrap="square"/>
+          <a:lstStyle/>
+          <a:p>
+            <a:pPr marL="0" algn="l"/>
+            <a:r>
+              <a:r>
+                <a:rPr lang="en-US" sz="1250">
+                  <a:solidFill>
+                    <a:srgbClr val="1A1A1A"/>
+                  </a:solidFill>
+                </a:rPr>
+                <a:t>Presented By,</a:t>
+              </a:r>
+            </a:r>
+            <a:endParaRPr lang="en-US" sz="1250"/>
+          </a:p>
+          <a:p>
+            <a:pPr marL="0" algn="l"/>
+            <a:r>
+              <a:r>
+                <a:rPr lang="en-US" sz="1250">
+                  <a:solidFill>
+                    <a:srgbClr val="1A1A1A"/>
+                  </a:solidFill>
+                </a:rPr>
+                <a:t>Student Name &amp; USN: __________________</a:t>
+              </a:r>
+            </a:r>
+            <a:endParaRPr lang="en-US" sz="1250"/>
+          </a:p>
+          <a:p>
+            <a:pPr marL="0" algn="l"/>
+            <a:r>
+              <a:r>
+                <a:rPr lang="en-US" sz="1250">
+                  <a:solidFill>
+                    <a:srgbClr val="1A1A1A"/>
+                  </a:solidFill>
+                </a:rPr>
+                <a:t>Student Name &amp; USN: __________________</a:t>
+              </a:r>
+            </a:r>
+            <a:endParaRPr lang="en-US" sz="1250"/>
+          </a:p>
+          <a:p>
+            <a:pPr marL="0" algn="l"/>
+            <a:r>
+              <a:r>
+                <a:rPr lang="en-US" sz="1250">
+                  <a:solidFill>
+                    <a:srgbClr val="1A1A1A"/>
+                  </a:solidFill>
+                </a:rPr>
+                <a:t>Semester &amp; Section: 7C</a:t>
+              </a:r>
+            </a:r>
+            <a:endParaRPr lang="en-US" sz="1250"/>
+          </a:p>
+          <a:p>
+            <a:pPr marL="0" algn="l"/>
+            <a:r>
+              <a:r>
+                <a:rPr lang="en-US" sz="1250">
+                  <a:solidFill>
+                    <a:srgbClr val="1A1A1A"/>
+                  </a:solidFill>
+                </a:rPr>
+                <a:t>Date: __________________</a:t>
+              </a:r>
+            </a:r>
+            <a:endParaRPr lang="en-US" sz="1250"/>
+          </a:p>
+        </p:txBody>
+      </p:sp>
+      <p:sp>
+        <p:nvSpPr>
+          <p:cNvPr id="10" name="TextBox 10"/>
+          <p:cNvSpPr/>
+          <p:nvPr/>
+        </p:nvSpPr>
+        <p:spPr>
+          <a:xfrm>
+            <a:off x="6700000" y="5050000"/>
+            <a:ext cx="5100000" cy="900000"/>
+          </a:xfrm>
+          <a:prstGeom prst="rect">
+            <a:avLst/>
+          </a:prstGeom>
+          <a:solidFill>
+            <a:srgbClr val="FFFFFF"/>
+          </a:solidFill>
+          <a:ln>
+            <a:noFill/>
+          </a:ln>
+        </p:spPr>
+        <p:txBody>
+          <a:bodyPr wrap="square"/>
+          <a:lstStyle/>
+          <a:p>
+            <a:pPr marL="0" algn="l"/>
+            <a:r>
+              <a:r>
+                <a:rPr lang="en-US" sz="1250">
+                  <a:solidFill>
+                    <a:srgbClr val="1A1A1A"/>
+                  </a:solidFill>
+                </a:rPr>
+                <a:t>Faculty In-Charge:</a:t>
+              </a:r>
+            </a:r>
+            <a:endParaRPr lang="en-US" sz="1250"/>
+          </a:p>
+          <a:p>
+            <a:pPr marL="0" algn="l"/>
+            <a:r>
+              <a:r>
+                <a:rPr lang="en-US" sz="1250">
+                  <a:solidFill>
+                    <a:srgbClr val="1A1A1A"/>
+                  </a:solidFill>
+                </a:rPr>
+                <a:t>Upeksha Prasad G</a:t>
+              </a:r>
+            </a:r>
+            <a:endParaRPr lang="en-US" sz="1250"/>
+          </a:p>
+          <a:p>
+            <a:pPr marL="0" algn="l"/>
+            <a:r>
+              <a:r>
+                <a:rPr lang="en-US" sz="1250">
+                  <a:solidFill>
+                    <a:srgbClr val="1A1A1A"/>
+                  </a:solidFill>
+                </a:rPr>
+                <a:t>Assistant Professor</a:t>
+              </a:r>
+            </a:r>
+            <a:endParaRPr lang="en-US" sz="1250"/>
+          </a:p>
+          <a:p>
+            <a:pPr marL="0" algn="l"/>
+            <a:r>
+              <a:r>
+                <a:rPr lang="en-US" sz="1250">
+                  <a:solidFill>
+                    <a:srgbClr val="1A1A1A"/>
+                  </a:solidFill>
+                </a:rPr>
+                <a:t>Department of Machine Learning</a:t>
+              </a:r>
+            </a:r>
+            <a:endParaRPr lang="en-US" sz="1250"/>
+          </a:p>
+          <a:p>
+            <a:pPr marL="0" algn="l"/>
+            <a:r>
+              <a:r>
+                <a:rPr lang="en-US" sz="1250">
+                  <a:solidFill>
+                    <a:srgbClr val="1A1A1A"/>
+                  </a:solidFill>
+                </a:rPr>
+                <a:t>BMS College of Engineering</a:t>
+              </a:r>
+            </a:r>
+            <a:endParaRPr lang="en-US" sz="1250"/>
+          </a:p>
+        </p:txBody>
+      </p:sp>
+    </p:spTree>
+  </p:cSld>
+  <p:clrMapOvr>
+    <a:masterClrMapping/>
+  </p:clrMapOvr>
+</p:sld>
+</file>
+
+<file path=ppt/slides/slide10.xml><?xml version="1.0" encoding="utf-8"?>
+<p:sld xmlns:a="http://schemas.openxmlformats.org/drawingml/2006/main" xmlns:r="http://schemas.openxmlformats.org/officeDocument/2006/relationships" xmlns:p="http://schemas.openxmlformats.org/presentationml/2006/main">
+  <p:cSld>
+    <p:spTree>
+      <p:nvGrpSpPr>
+        <p:cNvPr id="1" name=""/>
+        <p:cNvGrpSpPr/>
+        <p:nvPr/>
+      </p:nvGrpSpPr>
+      <p:grpSpPr>
+        <a:xfrm>
+          <a:off x="0" y="0"/>
+          <a:ext cx="0" cy="0"/>
+          <a:chOff x="0" y="0"/>
+          <a:chExt cx="0" cy="0"/>
+        </a:xfrm>
+      </p:grpSpPr>
+      <p:sp>
+        <p:nvSpPr>
+          <p:cNvPr id="2" name="TextBox 2"/>
+          <p:cNvSpPr/>
+          <p:nvPr/>
+        </p:nvSpPr>
+        <p:spPr>
+          <a:xfrm>
+            <a:off x="720000" y="420000"/>
             <a:ext cx="11200000" cy="850000"/>
           </a:xfrm>
           <a:prstGeom prst="rect">
             <a:avLst/>
           </a:prstGeom>
           <a:solidFill>
-            <a:srgbClr val="07131D"/>
+            <a:srgbClr val="FFFFFF"/>
           </a:solidFill>
           <a:ln>
             <a:noFill/>
@@ -118,10 +655,10 @@
                 <a:rPr lang="en-US" sz="3000">
                   <a:b/>
                   <a:solidFill>
-                    <a:srgbClr val="41D7C3"/>
-                  </a:solidFill>
-                </a:rPr>
-                <a:t>Privacy-Preserving Financial NER</a:t>
+                    <a:srgbClr val="0000CC"/>
+                  </a:solidFill>
+                </a:rPr>
+                <a:t>Discussion</a:t>
               </a:r>
             </a:r>
             <a:endParaRPr lang="en-US" sz="3000"/>
@@ -136,14 +673,14 @@
         </p:nvSpPr>
         <p:spPr>
           <a:xfrm>
-            <a:off x="720000" y="1300000"/>
+            <a:off x="720000" y="1250000"/>
             <a:ext cx="11200000" cy="600000"/>
           </a:xfrm>
           <a:prstGeom prst="rect">
             <a:avLst/>
           </a:prstGeom>
           <a:solidFill>
-            <a:srgbClr val="07131D"/>
+            <a:srgbClr val="FFFFFF"/>
           </a:solidFill>
           <a:ln>
             <a:noFill/>
@@ -158,10 +695,10 @@
               <a:r>
                 <a:rPr lang="en-US" sz="1450">
                   <a:solidFill>
-                    <a:srgbClr val="8CA7B1"/>
-                  </a:solidFill>
-                </a:rPr>
-                <a:t>Named Entity Recognition for automated PCI/PII detection</a:t>
+                    <a:srgbClr val="6B3E25"/>
+                  </a:solidFill>
+                </a:rPr>
+                <a:t>What the comparison tells us</a:t>
               </a:r>
             </a:r>
             <a:endParaRPr lang="en-US" sz="1450"/>
@@ -176,60 +713,74 @@
         </p:nvSpPr>
         <p:spPr>
           <a:xfrm>
-            <a:off x="950000" y="2300000"/>
+            <a:off x="950000" y="2200000"/>
             <a:ext cx="10500000" cy="4300000"/>
           </a:xfrm>
           <a:prstGeom prst="rect">
             <a:avLst/>
           </a:prstGeom>
           <a:solidFill>
-            <a:srgbClr val="07131D"/>
-          </a:solidFill>
-          <a:ln>
-            <a:noFill/>
-          </a:ln>
-        </p:spPr>
-        <p:txBody>
-          <a:bodyPr wrap="square"/>
-          <a:lstStyle/>
-          <a:p>
-            <a:pPr marL="0" algn="l"/>
-            <a:r>
-              <a:r>
-                <a:rPr lang="en-US" sz="2100">
-                  <a:solidFill>
-                    <a:srgbClr val="EAF4F4"/>
-                  </a:solidFill>
-                </a:rPr>
-                <a:t>• NLP activity: concept, implementation, validation and presentation</a:t>
-              </a:r>
-            </a:r>
-            <a:endParaRPr lang="en-US" sz="2100"/>
-          </a:p>
-          <a:p>
-            <a:pPr marL="0" algn="l"/>
-            <a:r>
-              <a:r>
-                <a:rPr lang="en-US" sz="2100">
-                  <a:solidFill>
-                    <a:srgbClr val="EAF4F4"/>
-                  </a:solidFill>
-                </a:rPr>
-                <a:t>• A separate project in the llm-aat repository</a:t>
-              </a:r>
-            </a:r>
-            <a:endParaRPr lang="en-US" sz="2100"/>
-          </a:p>
-          <a:p>
-            <a:pPr marL="0" algn="l"/>
-            <a:r>
-              <a:r>
-                <a:rPr lang="en-US" sz="2100">
-                  <a:solidFill>
-                    <a:srgbClr val="EAF4F4"/>
-                  </a:solidFill>
-                </a:rPr>
-                <a:t>• Synthetic data only; raw sensitive values stay behind the scanner</a:t>
+            <a:srgbClr val="FFFFFF"/>
+          </a:solidFill>
+          <a:ln>
+            <a:noFill/>
+          </a:ln>
+        </p:spPr>
+        <p:txBody>
+          <a:bodyPr wrap="square"/>
+          <a:lstStyle/>
+          <a:p>
+            <a:pPr marL="0" algn="l"/>
+            <a:r>
+              <a:r>
+                <a:rPr lang="en-US" sz="2100">
+                  <a:solidFill>
+                    <a:srgbClr val="1A1A1A"/>
+                  </a:solidFill>
+                </a:rPr>
+                <a:t>• Rules achieved perfect precision but lower recall because they miss contextual PERSON and ORGANIZATION entities</a:t>
+              </a:r>
+            </a:r>
+            <a:endParaRPr lang="en-US" sz="2100"/>
+          </a:p>
+          <a:p>
+            <a:pPr marL="0" algn="l"/>
+            <a:r>
+              <a:r>
+                <a:rPr lang="en-US" sz="2100">
+                  <a:solidFill>
+                    <a:srgbClr val="1A1A1A"/>
+                  </a:solidFill>
+                </a:rPr>
+                <a:t>• The perceptron recovered contextual entities with 0.9960 entity F1 on the templated corpus</a:t>
+              </a:r>
+            </a:r>
+            <a:endParaRPr lang="en-US" sz="2100"/>
+          </a:p>
+          <a:p>
+            <a:pPr marL="0" algn="l"/>
+            <a:r>
+              <a:r>
+                <a:rPr lang="en-US" sz="2100">
+                  <a:solidFill>
+                    <a:srgbClr val="1A1A1A"/>
+                  </a:solidFill>
+                </a:rPr>
+                <a:t>• The hybrid design adds explicit validation and remains auditable</a:t>
+              </a:r>
+            </a:r>
+            <a:endParaRPr lang="en-US" sz="2100"/>
+          </a:p>
+          <a:p>
+            <a:pPr marL="0" algn="l"/>
+            <a:r>
+              <a:r>
+                <a:rPr lang="en-US" sz="2100">
+                  <a:solidFill>
+                    <a:srgbClr val="1A1A1A"/>
+                  </a:solidFill>
+                </a:rPr>
+                <a:t>• The result is educational evidence, not a production generalization claim</a:t>
               </a:r>
             </a:r>
             <a:endParaRPr lang="en-US" sz="2100"/>
@@ -251,7 +802,7 @@
             <a:avLst/>
           </a:prstGeom>
           <a:solidFill>
-            <a:srgbClr val="07131D"/>
+            <a:srgbClr val="FFFFFF"/>
           </a:solidFill>
           <a:ln>
             <a:noFill/>
@@ -266,13 +817,534 @@
               <a:r>
                 <a:rPr lang="en-US" sz="900">
                   <a:solidFill>
-                    <a:srgbClr val="5C7A85"/>
-                  </a:solidFill>
-                </a:rPr>
-                <a:t>SentinelOS NLP activity  ·  1</a:t>
+                    <a:srgbClr val="6B3E25"/>
+                  </a:solidFill>
+                </a:rPr>
+                <a:t>Natural Language Processing for LLM · 24AM7PCLLM · 10</a:t>
               </a:r>
             </a:r>
             <a:endParaRPr lang="en-US" sz="900"/>
+          </a:p>
+        </p:txBody>
+      </p:sp>
+    </p:spTree>
+  </p:cSld>
+  <p:clrMapOvr>
+    <a:masterClrMapping/>
+  </p:clrMapOvr>
+</p:sld>
+</file>
+
+<file path=ppt/slides/slide11.xml><?xml version="1.0" encoding="utf-8"?>
+<p:sld xmlns:a="http://schemas.openxmlformats.org/drawingml/2006/main" xmlns:r="http://schemas.openxmlformats.org/officeDocument/2006/relationships" xmlns:p="http://schemas.openxmlformats.org/presentationml/2006/main">
+  <p:cSld>
+    <p:spTree>
+      <p:nvGrpSpPr>
+        <p:cNvPr id="1" name=""/>
+        <p:cNvGrpSpPr/>
+        <p:nvPr/>
+      </p:nvGrpSpPr>
+      <p:grpSpPr>
+        <a:xfrm>
+          <a:off x="0" y="0"/>
+          <a:ext cx="0" cy="0"/>
+          <a:chOff x="0" y="0"/>
+          <a:chExt cx="0" cy="0"/>
+        </a:xfrm>
+      </p:grpSpPr>
+      <p:sp>
+        <p:nvSpPr>
+          <p:cNvPr id="2" name="TextBox 2"/>
+          <p:cNvSpPr/>
+          <p:nvPr/>
+        </p:nvSpPr>
+        <p:spPr>
+          <a:xfrm>
+            <a:off x="720000" y="420000"/>
+            <a:ext cx="11200000" cy="850000"/>
+          </a:xfrm>
+          <a:prstGeom prst="rect">
+            <a:avLst/>
+          </a:prstGeom>
+          <a:solidFill>
+            <a:srgbClr val="FFFFFF"/>
+          </a:solidFill>
+          <a:ln>
+            <a:noFill/>
+          </a:ln>
+        </p:spPr>
+        <p:txBody>
+          <a:bodyPr wrap="square"/>
+          <a:lstStyle/>
+          <a:p>
+            <a:pPr marL="0" algn="l"/>
+            <a:r>
+              <a:r>
+                <a:rPr lang="en-US" sz="3000">
+                  <a:b/>
+                  <a:solidFill>
+                    <a:srgbClr val="0000CC"/>
+                  </a:solidFill>
+                </a:rPr>
+                <a:t>Conclusion</a:t>
+              </a:r>
+            </a:r>
+            <a:endParaRPr lang="en-US" sz="3000"/>
+          </a:p>
+        </p:txBody>
+      </p:sp>
+      <p:sp>
+        <p:nvSpPr>
+          <p:cNvPr id="3" name="TextBox 3"/>
+          <p:cNvSpPr/>
+          <p:nvPr/>
+        </p:nvSpPr>
+        <p:spPr>
+          <a:xfrm>
+            <a:off x="720000" y="1250000"/>
+            <a:ext cx="11200000" cy="600000"/>
+          </a:xfrm>
+          <a:prstGeom prst="rect">
+            <a:avLst/>
+          </a:prstGeom>
+          <a:solidFill>
+            <a:srgbClr val="FFFFFF"/>
+          </a:solidFill>
+          <a:ln>
+            <a:noFill/>
+          </a:ln>
+        </p:spPr>
+        <p:txBody>
+          <a:bodyPr wrap="square"/>
+          <a:lstStyle/>
+          <a:p>
+            <a:pPr marL="0" algn="l"/>
+            <a:r>
+              <a:r>
+                <a:rPr lang="en-US" sz="1450">
+                  <a:solidFill>
+                    <a:srgbClr val="6B3E25"/>
+                  </a:solidFill>
+                </a:rPr>
+                <a:t>A practical privacy-first NER contribution</a:t>
+              </a:r>
+            </a:r>
+            <a:endParaRPr lang="en-US" sz="1450"/>
+          </a:p>
+        </p:txBody>
+      </p:sp>
+      <p:sp>
+        <p:nvSpPr>
+          <p:cNvPr id="4" name="TextBox 4"/>
+          <p:cNvSpPr/>
+          <p:nvPr/>
+        </p:nvSpPr>
+        <p:spPr>
+          <a:xfrm>
+            <a:off x="950000" y="2200000"/>
+            <a:ext cx="10500000" cy="4300000"/>
+          </a:xfrm>
+          <a:prstGeom prst="rect">
+            <a:avLst/>
+          </a:prstGeom>
+          <a:solidFill>
+            <a:srgbClr val="FFFFFF"/>
+          </a:solidFill>
+          <a:ln>
+            <a:noFill/>
+          </a:ln>
+        </p:spPr>
+        <p:txBody>
+          <a:bodyPr wrap="square"/>
+          <a:lstStyle/>
+          <a:p>
+            <a:pPr marL="0" algn="l"/>
+            <a:r>
+              <a:r>
+                <a:rPr lang="en-US" sz="2100">
+                  <a:solidFill>
+                    <a:srgbClr val="1A1A1A"/>
+                  </a:solidFill>
+                </a:rPr>
+                <a:t>• The project implements a complete NLP workflow from dataset construction to API delivery</a:t>
+              </a:r>
+            </a:r>
+            <a:endParaRPr lang="en-US" sz="2100"/>
+          </a:p>
+          <a:p>
+            <a:pPr marL="0" algn="l"/>
+            <a:r>
+              <a:r>
+                <a:rPr lang="en-US" sz="2100">
+                  <a:solidFill>
+                    <a:srgbClr val="1A1A1A"/>
+                  </a:solidFill>
+                </a:rPr>
+                <a:t>• Contextual NER and deterministic financial validation complement each other</a:t>
+              </a:r>
+            </a:r>
+            <a:endParaRPr lang="en-US" sz="2100"/>
+          </a:p>
+          <a:p>
+            <a:pPr marL="0" algn="l"/>
+            <a:r>
+              <a:r>
+                <a:rPr lang="en-US" sz="2100">
+                  <a:solidFill>
+                    <a:srgbClr val="1A1A1A"/>
+                  </a:solidFill>
+                </a:rPr>
+                <a:t>• Future work: held-out templates, human annotations, multilingual text and transformer comparison</a:t>
+              </a:r>
+            </a:r>
+            <a:endParaRPr lang="en-US" sz="2100"/>
+          </a:p>
+        </p:txBody>
+      </p:sp>
+      <p:sp>
+        <p:nvSpPr>
+          <p:cNvPr id="5" name="TextBox 5"/>
+          <p:cNvSpPr/>
+          <p:nvPr/>
+        </p:nvSpPr>
+        <p:spPr>
+          <a:xfrm>
+            <a:off x="720000" y="6900000"/>
+            <a:ext cx="11200000" cy="250000"/>
+          </a:xfrm>
+          <a:prstGeom prst="rect">
+            <a:avLst/>
+          </a:prstGeom>
+          <a:solidFill>
+            <a:srgbClr val="FFFFFF"/>
+          </a:solidFill>
+          <a:ln>
+            <a:noFill/>
+          </a:ln>
+        </p:spPr>
+        <p:txBody>
+          <a:bodyPr wrap="square"/>
+          <a:lstStyle/>
+          <a:p>
+            <a:pPr marL="0" algn="l"/>
+            <a:r>
+              <a:r>
+                <a:rPr lang="en-US" sz="900">
+                  <a:solidFill>
+                    <a:srgbClr val="6B3E25"/>
+                  </a:solidFill>
+                </a:rPr>
+                <a:t>Natural Language Processing for LLM · 24AM7PCLLM · 11</a:t>
+              </a:r>
+            </a:r>
+            <a:endParaRPr lang="en-US" sz="900"/>
+          </a:p>
+        </p:txBody>
+      </p:sp>
+    </p:spTree>
+  </p:cSld>
+  <p:clrMapOvr>
+    <a:masterClrMapping/>
+  </p:clrMapOvr>
+</p:sld>
+</file>
+
+<file path=ppt/slides/slide12.xml><?xml version="1.0" encoding="utf-8"?>
+<p:sld xmlns:a="http://schemas.openxmlformats.org/drawingml/2006/main" xmlns:r="http://schemas.openxmlformats.org/officeDocument/2006/relationships" xmlns:p="http://schemas.openxmlformats.org/presentationml/2006/main">
+  <p:cSld>
+    <p:spTree>
+      <p:nvGrpSpPr>
+        <p:cNvPr id="1" name=""/>
+        <p:cNvGrpSpPr/>
+        <p:nvPr/>
+      </p:nvGrpSpPr>
+      <p:grpSpPr>
+        <a:xfrm>
+          <a:off x="0" y="0"/>
+          <a:ext cx="0" cy="0"/>
+          <a:chOff x="0" y="0"/>
+          <a:chExt cx="0" cy="0"/>
+        </a:xfrm>
+      </p:grpSpPr>
+      <p:sp>
+        <p:nvSpPr>
+          <p:cNvPr id="2" name="TextBox 2"/>
+          <p:cNvSpPr/>
+          <p:nvPr/>
+        </p:nvSpPr>
+        <p:spPr>
+          <a:xfrm>
+            <a:off x="720000" y="420000"/>
+            <a:ext cx="11200000" cy="850000"/>
+          </a:xfrm>
+          <a:prstGeom prst="rect">
+            <a:avLst/>
+          </a:prstGeom>
+          <a:solidFill>
+            <a:srgbClr val="FFFFFF"/>
+          </a:solidFill>
+          <a:ln>
+            <a:noFill/>
+          </a:ln>
+        </p:spPr>
+        <p:txBody>
+          <a:bodyPr wrap="square"/>
+          <a:lstStyle/>
+          <a:p>
+            <a:pPr marL="0" algn="l"/>
+            <a:r>
+              <a:r>
+                <a:rPr lang="en-US" sz="3000">
+                  <a:b/>
+                  <a:solidFill>
+                    <a:srgbClr val="0000CC"/>
+                  </a:solidFill>
+                </a:rPr>
+                <a:t>References</a:t>
+              </a:r>
+            </a:r>
+            <a:endParaRPr lang="en-US" sz="3000"/>
+          </a:p>
+        </p:txBody>
+      </p:sp>
+      <p:sp>
+        <p:nvSpPr>
+          <p:cNvPr id="3" name="TextBox 3"/>
+          <p:cNvSpPr/>
+          <p:nvPr/>
+        </p:nvSpPr>
+        <p:spPr>
+          <a:xfrm>
+            <a:off x="720000" y="1250000"/>
+            <a:ext cx="11200000" cy="600000"/>
+          </a:xfrm>
+          <a:prstGeom prst="rect">
+            <a:avLst/>
+          </a:prstGeom>
+          <a:solidFill>
+            <a:srgbClr val="FFFFFF"/>
+          </a:solidFill>
+          <a:ln>
+            <a:noFill/>
+          </a:ln>
+        </p:spPr>
+        <p:txBody>
+          <a:bodyPr wrap="square"/>
+          <a:lstStyle/>
+          <a:p>
+            <a:pPr marL="0" algn="l"/>
+            <a:r>
+              <a:r>
+                <a:rPr lang="en-US" sz="1450">
+                  <a:solidFill>
+                    <a:srgbClr val="6B3E25"/>
+                  </a:solidFill>
+                </a:rPr>
+                <a:t>Selected literature and standards</a:t>
+              </a:r>
+            </a:r>
+            <a:endParaRPr lang="en-US" sz="1450"/>
+          </a:p>
+        </p:txBody>
+      </p:sp>
+      <p:sp>
+        <p:nvSpPr>
+          <p:cNvPr id="4" name="TextBox 4"/>
+          <p:cNvSpPr/>
+          <p:nvPr/>
+        </p:nvSpPr>
+        <p:spPr>
+          <a:xfrm>
+            <a:off x="950000" y="2200000"/>
+            <a:ext cx="10500000" cy="4300000"/>
+          </a:xfrm>
+          <a:prstGeom prst="rect">
+            <a:avLst/>
+          </a:prstGeom>
+          <a:solidFill>
+            <a:srgbClr val="FFFFFF"/>
+          </a:solidFill>
+          <a:ln>
+            <a:noFill/>
+          </a:ln>
+        </p:spPr>
+        <p:txBody>
+          <a:bodyPr wrap="square"/>
+          <a:lstStyle/>
+          <a:p>
+            <a:pPr marL="0" algn="l"/>
+            <a:r>
+              <a:r>
+                <a:rPr lang="en-US" sz="2100">
+                  <a:solidFill>
+                    <a:srgbClr val="1A1A1A"/>
+                  </a:solidFill>
+                </a:rPr>
+                <a:t>• Lample et al. (2016), Neural Architectures for Named Entity Recognition</a:t>
+              </a:r>
+            </a:r>
+            <a:endParaRPr lang="en-US" sz="2100"/>
+          </a:p>
+          <a:p>
+            <a:pPr marL="0" algn="l"/>
+            <a:r>
+              <a:r>
+                <a:rPr lang="en-US" sz="2100">
+                  <a:solidFill>
+                    <a:srgbClr val="1A1A1A"/>
+                  </a:solidFill>
+                </a:rPr>
+                <a:t>• Devlin et al. (2019), BERT: Pre-training of Deep Bidirectional Transformers</a:t>
+              </a:r>
+            </a:r>
+            <a:endParaRPr lang="en-US" sz="2100"/>
+          </a:p>
+          <a:p>
+            <a:pPr marL="0" algn="l"/>
+            <a:r>
+              <a:r>
+                <a:rPr lang="en-US" sz="2100">
+                  <a:solidFill>
+                    <a:srgbClr val="1A1A1A"/>
+                  </a:solidFill>
+                </a:rPr>
+                <a:t>• Nadeau and Sekine (2007), A survey of named entity recognition and classification</a:t>
+              </a:r>
+            </a:r>
+            <a:endParaRPr lang="en-US" sz="2100"/>
+          </a:p>
+          <a:p>
+            <a:pPr marL="0" algn="l"/>
+            <a:r>
+              <a:r>
+                <a:rPr lang="en-US" sz="2100">
+                  <a:solidFill>
+                    <a:srgbClr val="1A1A1A"/>
+                  </a:solidFill>
+                </a:rPr>
+                <a:t>• Payment Card Industry Security Standards Council, PCI DSS v4.0.1</a:t>
+              </a:r>
+            </a:r>
+            <a:endParaRPr lang="en-US" sz="2100"/>
+          </a:p>
+          <a:p>
+            <a:pPr marL="0" algn="l"/>
+            <a:r>
+              <a:r>
+                <a:rPr lang="en-US" sz="2100">
+                  <a:solidFill>
+                    <a:srgbClr val="1A1A1A"/>
+                  </a:solidFill>
+                </a:rPr>
+                <a:t>• Luhn (1960), Computer for verifying numbers</a:t>
+              </a:r>
+            </a:r>
+            <a:endParaRPr lang="en-US" sz="2100"/>
+          </a:p>
+        </p:txBody>
+      </p:sp>
+      <p:sp>
+        <p:nvSpPr>
+          <p:cNvPr id="5" name="TextBox 5"/>
+          <p:cNvSpPr/>
+          <p:nvPr/>
+        </p:nvSpPr>
+        <p:spPr>
+          <a:xfrm>
+            <a:off x="720000" y="6900000"/>
+            <a:ext cx="11200000" cy="250000"/>
+          </a:xfrm>
+          <a:prstGeom prst="rect">
+            <a:avLst/>
+          </a:prstGeom>
+          <a:solidFill>
+            <a:srgbClr val="FFFFFF"/>
+          </a:solidFill>
+          <a:ln>
+            <a:noFill/>
+          </a:ln>
+        </p:spPr>
+        <p:txBody>
+          <a:bodyPr wrap="square"/>
+          <a:lstStyle/>
+          <a:p>
+            <a:pPr marL="0" algn="l"/>
+            <a:r>
+              <a:r>
+                <a:rPr lang="en-US" sz="900">
+                  <a:solidFill>
+                    <a:srgbClr val="6B3E25"/>
+                  </a:solidFill>
+                </a:rPr>
+                <a:t>Natural Language Processing for LLM · 24AM7PCLLM · 12</a:t>
+              </a:r>
+            </a:r>
+            <a:endParaRPr lang="en-US" sz="900"/>
+          </a:p>
+        </p:txBody>
+      </p:sp>
+    </p:spTree>
+  </p:cSld>
+  <p:clrMapOvr>
+    <a:masterClrMapping/>
+  </p:clrMapOvr>
+</p:sld>
+</file>
+
+<file path=ppt/slides/slide13.xml><?xml version="1.0" encoding="utf-8"?>
+<p:sld xmlns:a="http://schemas.openxmlformats.org/drawingml/2006/main" xmlns:r="http://schemas.openxmlformats.org/officeDocument/2006/relationships" xmlns:p="http://schemas.openxmlformats.org/presentationml/2006/main">
+  <p:cSld>
+    <p:spTree>
+      <p:nvGrpSpPr>
+        <p:cNvPr id="1" name=""/>
+        <p:cNvGrpSpPr/>
+        <p:nvPr/>
+      </p:nvGrpSpPr>
+      <p:grpSpPr>
+        <a:xfrm>
+          <a:off x="0" y="0"/>
+          <a:ext cx="0" cy="0"/>
+          <a:chOff x="0" y="0"/>
+          <a:chExt cx="0" cy="0"/>
+        </a:xfrm>
+      </p:grpSpPr>
+      <p:sp>
+        <p:nvSpPr>
+          <p:cNvPr id="2" name="TextBox 2"/>
+          <p:cNvSpPr/>
+          <p:nvPr/>
+        </p:nvSpPr>
+        <p:spPr>
+          <a:xfrm>
+            <a:off x="500000" y="2700000"/>
+            <a:ext cx="11600000" cy="1300000"/>
+          </a:xfrm>
+          <a:prstGeom prst="rect">
+            <a:avLst/>
+          </a:prstGeom>
+          <a:solidFill>
+            <a:srgbClr val="FFFFFF"/>
+          </a:solidFill>
+          <a:ln>
+            <a:noFill/>
+          </a:ln>
+        </p:spPr>
+        <p:txBody>
+          <a:bodyPr wrap="square"/>
+          <a:lstStyle/>
+          <a:p>
+            <a:pPr marL="0" algn="l"/>
+            <a:r>
+              <a:r>
+                <a:rPr lang="en-US" sz="4400">
+                  <a:solidFill>
+                    <a:srgbClr val="1A1A1A"/>
+                  </a:solidFill>
+                </a:rPr>
+                <a:t>Thank you !</a:t>
+              </a:r>
+            </a:r>
+            <a:endParaRPr lang="en-US" sz="4400"/>
           </a:p>
         </p:txBody>
       </p:sp>
@@ -309,14 +1381,14 @@
         </p:nvSpPr>
         <p:spPr>
           <a:xfrm>
-            <a:off x="720000" y="480000"/>
+            <a:off x="720000" y="420000"/>
             <a:ext cx="11200000" cy="850000"/>
           </a:xfrm>
           <a:prstGeom prst="rect">
             <a:avLst/>
           </a:prstGeom>
           <a:solidFill>
-            <a:srgbClr val="07131D"/>
+            <a:srgbClr val="FFFFFF"/>
           </a:solidFill>
           <a:ln>
             <a:noFill/>
@@ -332,10 +1404,10 @@
                 <a:rPr lang="en-US" sz="3000">
                   <a:b/>
                   <a:solidFill>
-                    <a:srgbClr val="41D7C3"/>
-                  </a:solidFill>
-                </a:rPr>
-                <a:t>The problem</a:t>
+                    <a:srgbClr val="0000CC"/>
+                  </a:solidFill>
+                </a:rPr>
+                <a:t>Agenda</a:t>
               </a:r>
             </a:r>
             <a:endParaRPr lang="en-US" sz="3000"/>
@@ -350,14 +1422,14 @@
         </p:nvSpPr>
         <p:spPr>
           <a:xfrm>
-            <a:off x="720000" y="1300000"/>
+            <a:off x="720000" y="1250000"/>
             <a:ext cx="11200000" cy="600000"/>
           </a:xfrm>
           <a:prstGeom prst="rect">
             <a:avLst/>
           </a:prstGeom>
           <a:solidFill>
-            <a:srgbClr val="07131D"/>
+            <a:srgbClr val="FFFFFF"/>
           </a:solidFill>
           <a:ln>
             <a:noFill/>
@@ -372,10 +1444,10 @@
               <a:r>
                 <a:rPr lang="en-US" sz="1450">
                   <a:solidFill>
-                    <a:srgbClr val="8CA7B1"/>
-                  </a:solidFill>
-                </a:rPr>
-                <a:t>Financial text carries high-impact sensitive entities</a:t>
+                    <a:srgbClr val="6B3E25"/>
+                  </a:solidFill>
+                </a:rPr>
+                <a:t>Alternative Assessment Tool (AAT)</a:t>
               </a:r>
             </a:r>
             <a:endParaRPr lang="en-US" sz="1450"/>
@@ -390,60 +1462,158 @@
         </p:nvSpPr>
         <p:spPr>
           <a:xfrm>
-            <a:off x="950000" y="2300000"/>
+            <a:off x="950000" y="2200000"/>
             <a:ext cx="10500000" cy="4300000"/>
           </a:xfrm>
           <a:prstGeom prst="rect">
             <a:avLst/>
           </a:prstGeom>
           <a:solidFill>
-            <a:srgbClr val="07131D"/>
-          </a:solidFill>
-          <a:ln>
-            <a:noFill/>
-          </a:ln>
-        </p:spPr>
-        <p:txBody>
-          <a:bodyPr wrap="square"/>
-          <a:lstStyle/>
-          <a:p>
-            <a:pPr marL="0" algn="l"/>
-            <a:r>
-              <a:r>
-                <a:rPr lang="en-US" sz="2100">
-                  <a:solidFill>
-                    <a:srgbClr val="EAF4F4"/>
-                  </a:solidFill>
-                </a:rPr>
-                <a:t>• Customer emails, support transcripts and payment logs may contain PII or cardholder data</a:t>
-              </a:r>
-            </a:r>
-            <a:endParaRPr lang="en-US" sz="2100"/>
-          </a:p>
-          <a:p>
-            <a:pPr marL="0" algn="l"/>
-            <a:r>
-              <a:r>
-                <a:rPr lang="en-US" sz="2100">
-                  <a:solidFill>
-                    <a:srgbClr val="EAF4F4"/>
-                  </a:solidFill>
-                </a:rPr>
-                <a:t>• Blindly sending raw text to analytics or LLM systems creates a privacy boundary failure</a:t>
-              </a:r>
-            </a:r>
-            <a:endParaRPr lang="en-US" sz="2100"/>
-          </a:p>
-          <a:p>
-            <a:pPr marL="0" algn="l"/>
-            <a:r>
-              <a:r>
-                <a:rPr lang="en-US" sz="2100">
-                  <a:solidFill>
-                    <a:srgbClr val="EAF4F4"/>
-                  </a:solidFill>
-                </a:rPr>
-                <a:t>• Goal: detect, classify, validate and redact before downstream processing</a:t>
+            <a:srgbClr val="FFFFFF"/>
+          </a:solidFill>
+          <a:ln>
+            <a:noFill/>
+          </a:ln>
+        </p:spPr>
+        <p:txBody>
+          <a:bodyPr wrap="square"/>
+          <a:lstStyle/>
+          <a:p>
+            <a:pPr marL="0" algn="l"/>
+            <a:r>
+              <a:r>
+                <a:rPr lang="en-US" sz="2100">
+                  <a:solidFill>
+                    <a:srgbClr val="1A1A1A"/>
+                  </a:solidFill>
+                </a:rPr>
+                <a:t>• Introduction</a:t>
+              </a:r>
+            </a:r>
+            <a:endParaRPr lang="en-US" sz="2100"/>
+          </a:p>
+          <a:p>
+            <a:pPr marL="0" algn="l"/>
+            <a:r>
+              <a:r>
+                <a:rPr lang="en-US" sz="2100">
+                  <a:solidFill>
+                    <a:srgbClr val="1A1A1A"/>
+                  </a:solidFill>
+                </a:rPr>
+                <a:t>• Selected NLP Topic Overview</a:t>
+              </a:r>
+            </a:r>
+            <a:endParaRPr lang="en-US" sz="2100"/>
+          </a:p>
+          <a:p>
+            <a:pPr marL="0" algn="l"/>
+            <a:r>
+              <a:r>
+                <a:rPr lang="en-US" sz="2100">
+                  <a:solidFill>
+                    <a:srgbClr val="1A1A1A"/>
+                  </a:solidFill>
+                </a:rPr>
+                <a:t>• Real-Time Application / API Identified</a:t>
+              </a:r>
+            </a:r>
+            <a:endParaRPr lang="en-US" sz="2100"/>
+          </a:p>
+          <a:p>
+            <a:pPr marL="0" algn="l"/>
+            <a:r>
+              <a:r>
+                <a:rPr lang="en-US" sz="2100">
+                  <a:solidFill>
+                    <a:srgbClr val="1A1A1A"/>
+                  </a:solidFill>
+                </a:rPr>
+                <a:t>• NLP Model / Architecture Study</a:t>
+              </a:r>
+            </a:r>
+            <a:endParaRPr lang="en-US" sz="2100"/>
+          </a:p>
+          <a:p>
+            <a:pPr marL="0" algn="l"/>
+            <a:r>
+              <a:r>
+                <a:rPr lang="en-US" sz="2100">
+                  <a:solidFill>
+                    <a:srgbClr val="1A1A1A"/>
+                  </a:solidFill>
+                </a:rPr>
+                <a:t>• Dataset and Preprocessing</a:t>
+              </a:r>
+            </a:r>
+            <a:endParaRPr lang="en-US" sz="2100"/>
+          </a:p>
+          <a:p>
+            <a:pPr marL="0" algn="l"/>
+            <a:r>
+              <a:r>
+                <a:rPr lang="en-US" sz="2100">
+                  <a:solidFill>
+                    <a:srgbClr val="1A1A1A"/>
+                  </a:solidFill>
+                </a:rPr>
+                <a:t>• Implementation Methodology</a:t>
+              </a:r>
+            </a:r>
+            <a:endParaRPr lang="en-US" sz="2100"/>
+          </a:p>
+          <a:p>
+            <a:pPr marL="0" algn="l"/>
+            <a:r>
+              <a:r>
+                <a:rPr lang="en-US" sz="2100">
+                  <a:solidFill>
+                    <a:srgbClr val="1A1A1A"/>
+                  </a:solidFill>
+                </a:rPr>
+                <a:t>• Results and Evaluation</a:t>
+              </a:r>
+            </a:r>
+            <a:endParaRPr lang="en-US" sz="2100"/>
+          </a:p>
+          <a:p>
+            <a:pPr marL="0" algn="l"/>
+            <a:r>
+              <a:r>
+                <a:rPr lang="en-US" sz="2100">
+                  <a:solidFill>
+                    <a:srgbClr val="1A1A1A"/>
+                  </a:solidFill>
+                </a:rPr>
+                <a:t>• Discussion</a:t>
+              </a:r>
+            </a:r>
+            <a:endParaRPr lang="en-US" sz="2100"/>
+          </a:p>
+          <a:p>
+            <a:pPr marL="0" algn="l"/>
+            <a:r>
+              <a:r>
+                <a:rPr lang="en-US" sz="2100">
+                  <a:solidFill>
+                    <a:srgbClr val="1A1A1A"/>
+                  </a:solidFill>
+                </a:rPr>
+                <a:t>• Conclusion</a:t>
+              </a:r>
+            </a:r>
+            <a:endParaRPr lang="en-US" sz="2100"/>
+          </a:p>
+          <a:p>
+            <a:pPr marL="0" algn="l"/>
+            <a:r>
+              <a:r>
+                <a:rPr lang="en-US" sz="2100">
+                  <a:solidFill>
+                    <a:srgbClr val="1A1A1A"/>
+                  </a:solidFill>
+                </a:rPr>
+                <a:t>• References</a:t>
               </a:r>
             </a:r>
             <a:endParaRPr lang="en-US" sz="2100"/>
@@ -465,7 +1635,7 @@
             <a:avLst/>
           </a:prstGeom>
           <a:solidFill>
-            <a:srgbClr val="07131D"/>
+            <a:srgbClr val="FFFFFF"/>
           </a:solidFill>
           <a:ln>
             <a:noFill/>
@@ -480,10 +1650,10 @@
               <a:r>
                 <a:rPr lang="en-US" sz="900">
                   <a:solidFill>
-                    <a:srgbClr val="5C7A85"/>
-                  </a:solidFill>
-                </a:rPr>
-                <a:t>SentinelOS NLP activity  ·  2</a:t>
+                    <a:srgbClr val="6B3E25"/>
+                  </a:solidFill>
+                </a:rPr>
+                <a:t>Natural Language Processing for LLM · 24AM7PCLLM · 2</a:t>
               </a:r>
             </a:r>
             <a:endParaRPr lang="en-US" sz="900"/>
@@ -523,14 +1693,14 @@
         </p:nvSpPr>
         <p:spPr>
           <a:xfrm>
-            <a:off x="720000" y="480000"/>
+            <a:off x="720000" y="420000"/>
             <a:ext cx="11200000" cy="850000"/>
           </a:xfrm>
           <a:prstGeom prst="rect">
             <a:avLst/>
           </a:prstGeom>
           <a:solidFill>
-            <a:srgbClr val="07131D"/>
+            <a:srgbClr val="FFFFFF"/>
           </a:solidFill>
           <a:ln>
             <a:noFill/>
@@ -546,10 +1716,10 @@
                 <a:rPr lang="en-US" sz="3000">
                   <a:b/>
                   <a:solidFill>
-                    <a:srgbClr val="41D7C3"/>
-                  </a:solidFill>
-                </a:rPr>
-                <a:t>Why NER is the right topic</a:t>
+                    <a:srgbClr val="0000CC"/>
+                  </a:solidFill>
+                </a:rPr>
+                <a:t>Introduction</a:t>
               </a:r>
             </a:r>
             <a:endParaRPr lang="en-US" sz="3000"/>
@@ -564,14 +1734,14 @@
         </p:nvSpPr>
         <p:spPr>
           <a:xfrm>
-            <a:off x="720000" y="1300000"/>
+            <a:off x="720000" y="1250000"/>
             <a:ext cx="11200000" cy="600000"/>
           </a:xfrm>
           <a:prstGeom prst="rect">
             <a:avLst/>
           </a:prstGeom>
           <a:solidFill>
-            <a:srgbClr val="07131D"/>
+            <a:srgbClr val="FFFFFF"/>
           </a:solidFill>
           <a:ln>
             <a:noFill/>
@@ -586,10 +1756,10 @@
               <a:r>
                 <a:rPr lang="en-US" sz="1450">
                   <a:solidFill>
-                    <a:srgbClr val="8CA7B1"/>
-                  </a:solidFill>
-                </a:rPr>
-                <a:t>A domain-specific application of a core syllabus technique</a:t>
+                    <a:srgbClr val="6B3E25"/>
+                  </a:solidFill>
+                </a:rPr>
+                <a:t>Why sensitive financial text needs a privacy boundary</a:t>
               </a:r>
             </a:r>
             <a:endParaRPr lang="en-US" sz="1450"/>
@@ -604,60 +1774,74 @@
         </p:nvSpPr>
         <p:spPr>
           <a:xfrm>
-            <a:off x="950000" y="2300000"/>
+            <a:off x="950000" y="2200000"/>
             <a:ext cx="10500000" cy="4300000"/>
           </a:xfrm>
           <a:prstGeom prst="rect">
             <a:avLst/>
           </a:prstGeom>
           <a:solidFill>
-            <a:srgbClr val="07131D"/>
-          </a:solidFill>
-          <a:ln>
-            <a:noFill/>
-          </a:ln>
-        </p:spPr>
-        <p:txBody>
-          <a:bodyPr wrap="square"/>
-          <a:lstStyle/>
-          <a:p>
-            <a:pPr marL="0" algn="l"/>
-            <a:r>
-              <a:r>
-                <a:rPr lang="en-US" sz="2100">
-                  <a:solidFill>
-                    <a:srgbClr val="EAF4F4"/>
-                  </a:solidFill>
-                </a:rPr>
-                <a:t>• BIO tagging labels the beginning and continuation of each entity span</a:t>
-              </a:r>
-            </a:r>
-            <a:endParaRPr lang="en-US" sz="2100"/>
-          </a:p>
-          <a:p>
-            <a:pPr marL="0" algn="l"/>
-            <a:r>
-              <a:r>
-                <a:rPr lang="en-US" sz="2100">
-                  <a:solidFill>
-                    <a:srgbClr val="EAF4F4"/>
-                  </a:solidFill>
-                </a:rPr>
-                <a:t>• Labels: PERSON, EMAIL, PHONE, CARD_NUMBER, ACCOUNT_NUMBER, TAX_ID, ADDRESS, TRANSACTION_ID and ORGANIZATION</a:t>
-              </a:r>
-            </a:r>
-            <a:endParaRPr lang="en-US" sz="2100"/>
-          </a:p>
-          <a:p>
-            <a:pPr marL="0" algn="l"/>
-            <a:r>
-              <a:r>
-                <a:rPr lang="en-US" sz="2100">
-                  <a:solidFill>
-                    <a:srgbClr val="EAF4F4"/>
-                  </a:solidFill>
-                </a:rPr>
-                <a:t>• The output is useful for both redaction and audit evidence</a:t>
+            <a:srgbClr val="FFFFFF"/>
+          </a:solidFill>
+          <a:ln>
+            <a:noFill/>
+          </a:ln>
+        </p:spPr>
+        <p:txBody>
+          <a:bodyPr wrap="square"/>
+          <a:lstStyle/>
+          <a:p>
+            <a:pPr marL="0" algn="l"/>
+            <a:r>
+              <a:r>
+                <a:rPr lang="en-US" sz="2100">
+                  <a:solidFill>
+                    <a:srgbClr val="1A1A1A"/>
+                  </a:solidFill>
+                </a:rPr>
+                <a:t>• Financial institutions process emails, support cases, transactions and operational logs</a:t>
+              </a:r>
+            </a:r>
+            <a:endParaRPr lang="en-US" sz="2100"/>
+          </a:p>
+          <a:p>
+            <a:pPr marL="0" algn="l"/>
+            <a:r>
+              <a:r>
+                <a:rPr lang="en-US" sz="2100">
+                  <a:solidFill>
+                    <a:srgbClr val="1A1A1A"/>
+                  </a:solidFill>
+                </a:rPr>
+                <a:t>• These texts may contain PII or payment-card information</a:t>
+              </a:r>
+            </a:r>
+            <a:endParaRPr lang="en-US" sz="2100"/>
+          </a:p>
+          <a:p>
+            <a:pPr marL="0" algn="l"/>
+            <a:r>
+              <a:r>
+                <a:rPr lang="en-US" sz="2100">
+                  <a:solidFill>
+                    <a:srgbClr val="1A1A1A"/>
+                  </a:solidFill>
+                </a:rPr>
+                <a:t>• NER can identify sensitive spans before analytics or language-model processing</a:t>
+              </a:r>
+            </a:r>
+            <a:endParaRPr lang="en-US" sz="2100"/>
+          </a:p>
+          <a:p>
+            <a:pPr marL="0" algn="l"/>
+            <a:r>
+              <a:r>
+                <a:rPr lang="en-US" sz="2100">
+                  <a:solidFill>
+                    <a:srgbClr val="1A1A1A"/>
+                  </a:solidFill>
+                </a:rPr>
+                <a:t>• This project demonstrates detection, validation and redaction with synthetic data</a:t>
               </a:r>
             </a:r>
             <a:endParaRPr lang="en-US" sz="2100"/>
@@ -679,7 +1863,7 @@
             <a:avLst/>
           </a:prstGeom>
           <a:solidFill>
-            <a:srgbClr val="07131D"/>
+            <a:srgbClr val="FFFFFF"/>
           </a:solidFill>
           <a:ln>
             <a:noFill/>
@@ -694,10 +1878,10 @@
               <a:r>
                 <a:rPr lang="en-US" sz="900">
                   <a:solidFill>
-                    <a:srgbClr val="5C7A85"/>
-                  </a:solidFill>
-                </a:rPr>
-                <a:t>SentinelOS NLP activity  ·  3</a:t>
+                    <a:srgbClr val="6B3E25"/>
+                  </a:solidFill>
+                </a:rPr>
+                <a:t>Natural Language Processing for LLM · 24AM7PCLLM · 3</a:t>
               </a:r>
             </a:r>
             <a:endParaRPr lang="en-US" sz="900"/>
@@ -737,14 +1921,14 @@
         </p:nvSpPr>
         <p:spPr>
           <a:xfrm>
-            <a:off x="720000" y="480000"/>
+            <a:off x="720000" y="420000"/>
             <a:ext cx="11200000" cy="850000"/>
           </a:xfrm>
           <a:prstGeom prst="rect">
             <a:avLst/>
           </a:prstGeom>
           <a:solidFill>
-            <a:srgbClr val="07131D"/>
+            <a:srgbClr val="FFFFFF"/>
           </a:solidFill>
           <a:ln>
             <a:noFill/>
@@ -760,10 +1944,10 @@
                 <a:rPr lang="en-US" sz="3000">
                   <a:b/>
                   <a:solidFill>
-                    <a:srgbClr val="41D7C3"/>
-                  </a:solidFill>
-                </a:rPr>
-                <a:t>System architecture</a:t>
+                    <a:srgbClr val="0000CC"/>
+                  </a:solidFill>
+                </a:rPr>
+                <a:t>Selected NLP Topic Overview</a:t>
               </a:r>
             </a:r>
             <a:endParaRPr lang="en-US" sz="3000"/>
@@ -778,14 +1962,14 @@
         </p:nvSpPr>
         <p:spPr>
           <a:xfrm>
-            <a:off x="720000" y="1300000"/>
+            <a:off x="720000" y="1250000"/>
             <a:ext cx="11200000" cy="600000"/>
           </a:xfrm>
           <a:prstGeom prst="rect">
             <a:avLst/>
           </a:prstGeom>
           <a:solidFill>
-            <a:srgbClr val="07131D"/>
+            <a:srgbClr val="FFFFFF"/>
           </a:solidFill>
           <a:ln>
             <a:noFill/>
@@ -800,10 +1984,10 @@
               <a:r>
                 <a:rPr lang="en-US" sz="1450">
                   <a:solidFill>
-                    <a:srgbClr val="8CA7B1"/>
-                  </a:solidFill>
-                </a:rPr>
-                <a:t>A transparent hybrid pipeline</a:t>
+                    <a:srgbClr val="6B3E25"/>
+                  </a:solidFill>
+                </a:rPr>
+                <a:t>Named Entity Recognition (NER)</a:t>
               </a:r>
             </a:r>
             <a:endParaRPr lang="en-US" sz="1450"/>
@@ -818,74 +2002,74 @@
         </p:nvSpPr>
         <p:spPr>
           <a:xfrm>
-            <a:off x="950000" y="2300000"/>
+            <a:off x="950000" y="2200000"/>
             <a:ext cx="10500000" cy="4300000"/>
           </a:xfrm>
           <a:prstGeom prst="rect">
             <a:avLst/>
           </a:prstGeom>
           <a:solidFill>
-            <a:srgbClr val="07131D"/>
-          </a:solidFill>
-          <a:ln>
-            <a:noFill/>
-          </a:ln>
-        </p:spPr>
-        <p:txBody>
-          <a:bodyPr wrap="square"/>
-          <a:lstStyle/>
-          <a:p>
-            <a:pPr marL="0" algn="l"/>
-            <a:r>
-              <a:r>
-                <a:rPr lang="en-US" sz="2100">
-                  <a:solidFill>
-                    <a:srgbClr val="EAF4F4"/>
-                  </a:solidFill>
-                </a:rPr>
-                <a:t>• Tokenizer preserves character offsets and produces BIO labels</a:t>
-              </a:r>
-            </a:r>
-            <a:endParaRPr lang="en-US" sz="2100"/>
-          </a:p>
-          <a:p>
-            <a:pPr marL="0" algn="l"/>
-            <a:r>
-              <a:r>
-                <a:rPr lang="en-US" sz="2100">
-                  <a:solidFill>
-                    <a:srgbClr val="EAF4F4"/>
-                  </a:solidFill>
-                </a:rPr>
-                <a:t>• Rules layer validates structured identifiers and applies a Luhn checksum to card-like values</a:t>
-              </a:r>
-            </a:r>
-            <a:endParaRPr lang="en-US" sz="2100"/>
-          </a:p>
-          <a:p>
-            <a:pPr marL="0" algn="l"/>
-            <a:r>
-              <a:r>
-                <a:rPr lang="en-US" sz="2100">
-                  <a:solidFill>
-                    <a:srgbClr val="EAF4F4"/>
-                  </a:solidFill>
-                </a:rPr>
-                <a:t>• Averaged perceptron uses word shape, context, prefixes, suffixes and previous BIO labels</a:t>
-              </a:r>
-            </a:r>
-            <a:endParaRPr lang="en-US" sz="2100"/>
-          </a:p>
-          <a:p>
-            <a:pPr marL="0" algn="l"/>
-            <a:r>
-              <a:r>
-                <a:rPr lang="en-US" sz="2100">
-                  <a:solidFill>
-                    <a:srgbClr val="EAF4F4"/>
-                  </a:solidFill>
-                </a:rPr>
-                <a:t>• Overlap resolver returns masked spans and a privacy note</a:t>
+            <a:srgbClr val="FFFFFF"/>
+          </a:solidFill>
+          <a:ln>
+            <a:noFill/>
+          </a:ln>
+        </p:spPr>
+        <p:txBody>
+          <a:bodyPr wrap="square"/>
+          <a:lstStyle/>
+          <a:p>
+            <a:pPr marL="0" algn="l"/>
+            <a:r>
+              <a:r>
+                <a:rPr lang="en-US" sz="2100">
+                  <a:solidFill>
+                    <a:srgbClr val="1A1A1A"/>
+                  </a:solidFill>
+                </a:rPr>
+                <a:t>• NER assigns semantic labels to text spans using BIO tagging</a:t>
+              </a:r>
+            </a:r>
+            <a:endParaRPr lang="en-US" sz="2100"/>
+          </a:p>
+          <a:p>
+            <a:pPr marL="0" algn="l"/>
+            <a:r>
+              <a:r>
+                <a:rPr lang="en-US" sz="2100">
+                  <a:solidFill>
+                    <a:srgbClr val="1A1A1A"/>
+                  </a:solidFill>
+                </a:rPr>
+                <a:t>• Financial labels: PERSON, EMAIL, PHONE, CARD_NUMBER, ACCOUNT_NUMBER, TAX_ID, ADDRESS, TRANSACTION_ID and ORGANIZATION</a:t>
+              </a:r>
+            </a:r>
+            <a:endParaRPr lang="en-US" sz="2100"/>
+          </a:p>
+          <a:p>
+            <a:pPr marL="0" algn="l"/>
+            <a:r>
+              <a:r>
+                <a:rPr lang="en-US" sz="2100">
+                  <a:solidFill>
+                    <a:srgbClr val="1A1A1A"/>
+                  </a:solidFill>
+                </a:rPr>
+                <a:t>• Application: local compliance data-loss prevention for financial text</a:t>
+              </a:r>
+            </a:r>
+            <a:endParaRPr lang="en-US" sz="2100"/>
+          </a:p>
+          <a:p>
+            <a:pPr marL="0" algn="l"/>
+            <a:r>
+              <a:r>
+                <a:rPr lang="en-US" sz="2100">
+                  <a:solidFill>
+                    <a:srgbClr val="1A1A1A"/>
+                  </a:solidFill>
+                </a:rPr>
+                <a:t>• Challenge: protect against false negatives without creating excessive false positives</a:t>
               </a:r>
             </a:r>
             <a:endParaRPr lang="en-US" sz="2100"/>
@@ -907,7 +2091,7 @@
             <a:avLst/>
           </a:prstGeom>
           <a:solidFill>
-            <a:srgbClr val="07131D"/>
+            <a:srgbClr val="FFFFFF"/>
           </a:solidFill>
           <a:ln>
             <a:noFill/>
@@ -922,10 +2106,10 @@
               <a:r>
                 <a:rPr lang="en-US" sz="900">
                   <a:solidFill>
-                    <a:srgbClr val="5C7A85"/>
-                  </a:solidFill>
-                </a:rPr>
-                <a:t>SentinelOS NLP activity  ·  4</a:t>
+                    <a:srgbClr val="6B3E25"/>
+                  </a:solidFill>
+                </a:rPr>
+                <a:t>Natural Language Processing for LLM · 24AM7PCLLM · 4</a:t>
               </a:r>
             </a:r>
             <a:endParaRPr lang="en-US" sz="900"/>
@@ -965,14 +2149,14 @@
         </p:nvSpPr>
         <p:spPr>
           <a:xfrm>
-            <a:off x="720000" y="480000"/>
+            <a:off x="720000" y="420000"/>
             <a:ext cx="11200000" cy="850000"/>
           </a:xfrm>
           <a:prstGeom prst="rect">
             <a:avLst/>
           </a:prstGeom>
           <a:solidFill>
-            <a:srgbClr val="07131D"/>
+            <a:srgbClr val="FFFFFF"/>
           </a:solidFill>
           <a:ln>
             <a:noFill/>
@@ -988,10 +2172,10 @@
                 <a:rPr lang="en-US" sz="3000">
                   <a:b/>
                   <a:solidFill>
-                    <a:srgbClr val="41D7C3"/>
-                  </a:solidFill>
-                </a:rPr>
-                <a:t>Dataset and experiment</a:t>
+                    <a:srgbClr val="0000CC"/>
+                  </a:solidFill>
+                </a:rPr>
+                <a:t>Real-Time Application / API Identified</a:t>
               </a:r>
             </a:r>
             <a:endParaRPr lang="en-US" sz="3000"/>
@@ -1006,14 +2190,14 @@
         </p:nvSpPr>
         <p:spPr>
           <a:xfrm>
-            <a:off x="720000" y="1300000"/>
+            <a:off x="720000" y="1250000"/>
             <a:ext cx="11200000" cy="600000"/>
           </a:xfrm>
           <a:prstGeom prst="rect">
             <a:avLst/>
           </a:prstGeom>
           <a:solidFill>
-            <a:srgbClr val="07131D"/>
+            <a:srgbClr val="FFFFFF"/>
           </a:solidFill>
           <a:ln>
             <a:noFill/>
@@ -1028,10 +2212,10 @@
               <a:r>
                 <a:rPr lang="en-US" sz="1450">
                   <a:solidFill>
-                    <a:srgbClr val="8CA7B1"/>
-                  </a:solidFill>
-                </a:rPr>
-                <a:t>Reproducible synthetic financial corpus</a:t>
+                    <a:srgbClr val="6B3E25"/>
+                  </a:solidFill>
+                </a:rPr>
+                <a:t>Privacy-preserving financial text redaction service</a:t>
               </a:r>
             </a:r>
             <a:endParaRPr lang="en-US" sz="1450"/>
@@ -1046,74 +2230,74 @@
         </p:nvSpPr>
         <p:spPr>
           <a:xfrm>
-            <a:off x="950000" y="2300000"/>
+            <a:off x="950000" y="2200000"/>
             <a:ext cx="10500000" cy="4300000"/>
           </a:xfrm>
           <a:prstGeom prst="rect">
             <a:avLst/>
           </a:prstGeom>
           <a:solidFill>
-            <a:srgbClr val="07131D"/>
-          </a:solidFill>
-          <a:ln>
-            <a:noFill/>
-          </a:ln>
-        </p:spPr>
-        <p:txBody>
-          <a:bodyPr wrap="square"/>
-          <a:lstStyle/>
-          <a:p>
-            <a:pPr marL="0" algn="l"/>
-            <a:r>
-              <a:r>
-                <a:rPr lang="en-US" sz="2100">
-                  <a:solidFill>
-                    <a:srgbClr val="EAF4F4"/>
-                  </a:solidFill>
-                </a:rPr>
-                <a:t>• 600 examples generated from payment, KYC, refund, billing and support templates</a:t>
-              </a:r>
-            </a:r>
-            <a:endParaRPr lang="en-US" sz="2100"/>
-          </a:p>
-          <a:p>
-            <a:pPr marL="0" algn="l"/>
-            <a:r>
-              <a:r>
-                <a:rPr lang="en-US" sz="2100">
-                  <a:solidFill>
-                    <a:srgbClr val="EAF4F4"/>
-                  </a:solidFill>
-                </a:rPr>
-                <a:t>• 70% train · 15% development · 15% test</a:t>
-              </a:r>
-            </a:r>
-            <a:endParaRPr lang="en-US" sz="2100"/>
-          </a:p>
-          <a:p>
-            <a:pPr marL="0" algn="l"/>
-            <a:r>
-              <a:r>
-                <a:rPr lang="en-US" sz="2100">
-                  <a:solidFill>
-                    <a:srgbClr val="EAF4F4"/>
-                  </a:solidFill>
-                </a:rPr>
-                <a:t>• Seed: 42 · eight training epochs · exact character-span evaluation</a:t>
-              </a:r>
-            </a:r>
-            <a:endParaRPr lang="en-US" sz="2100"/>
-          </a:p>
-          <a:p>
-            <a:pPr marL="0" algn="l"/>
-            <a:r>
-              <a:r>
-                <a:rPr lang="en-US" sz="2100">
-                  <a:solidFill>
-                    <a:srgbClr val="EAF4F4"/>
-                  </a:solidFill>
-                </a:rPr>
-                <a:t>• No real personal or payment data is used</a:t>
+            <a:srgbClr val="FFFFFF"/>
+          </a:solidFill>
+          <a:ln>
+            <a:noFill/>
+          </a:ln>
+        </p:spPr>
+        <p:txBody>
+          <a:bodyPr wrap="square"/>
+          <a:lstStyle/>
+          <a:p>
+            <a:pPr marL="0" algn="l"/>
+            <a:r>
+              <a:r>
+                <a:rPr lang="en-US" sz="2100">
+                  <a:solidFill>
+                    <a:srgbClr val="1A1A1A"/>
+                  </a:solidFill>
+                </a:rPr>
+                <a:t>• API endpoints: GET /health, GET /demo and POST /redact</a:t>
+              </a:r>
+            </a:r>
+            <a:endParaRPr lang="en-US" sz="2100"/>
+          </a:p>
+          <a:p>
+            <a:pPr marL="0" algn="l"/>
+            <a:r>
+              <a:r>
+                <a:rPr lang="en-US" sz="2100">
+                  <a:solidFill>
+                    <a:srgbClr val="1A1A1A"/>
+                  </a:solidFill>
+                </a:rPr>
+                <a:t>• Input is raw text in the local scanner; output is masked text and entity metadata</a:t>
+              </a:r>
+            </a:r>
+            <a:endParaRPr lang="en-US" sz="2100"/>
+          </a:p>
+          <a:p>
+            <a:pPr marL="0" algn="l"/>
+            <a:r>
+              <a:r>
+                <a:rPr lang="en-US" sz="2100">
+                  <a:solidFill>
+                    <a:srgbClr val="1A1A1A"/>
+                  </a:solidFill>
+                </a:rPr>
+                <a:t>• The service can sit before an LLM, ticketing system, data warehouse or monitoring tool</a:t>
+              </a:r>
+            </a:r>
+            <a:endParaRPr lang="en-US" sz="2100"/>
+          </a:p>
+          <a:p>
+            <a:pPr marL="0" algn="l"/>
+            <a:r>
+              <a:r>
+                <a:rPr lang="en-US" sz="2100">
+                  <a:solidFill>
+                    <a:srgbClr val="1A1A1A"/>
+                  </a:solidFill>
+                </a:rPr>
+                <a:t>• Raw values should remain inside a controlled scanning boundary</a:t>
               </a:r>
             </a:r>
             <a:endParaRPr lang="en-US" sz="2100"/>
@@ -1135,7 +2319,7 @@
             <a:avLst/>
           </a:prstGeom>
           <a:solidFill>
-            <a:srgbClr val="07131D"/>
+            <a:srgbClr val="FFFFFF"/>
           </a:solidFill>
           <a:ln>
             <a:noFill/>
@@ -1150,10 +2334,10 @@
               <a:r>
                 <a:rPr lang="en-US" sz="900">
                   <a:solidFill>
-                    <a:srgbClr val="5C7A85"/>
-                  </a:solidFill>
-                </a:rPr>
-                <a:t>SentinelOS NLP activity  ·  5</a:t>
+                    <a:srgbClr val="6B3E25"/>
+                  </a:solidFill>
+                </a:rPr>
+                <a:t>Natural Language Processing for LLM · 24AM7PCLLM · 5</a:t>
               </a:r>
             </a:r>
             <a:endParaRPr lang="en-US" sz="900"/>
@@ -1193,14 +2377,14 @@
         </p:nvSpPr>
         <p:spPr>
           <a:xfrm>
-            <a:off x="720000" y="480000"/>
+            <a:off x="720000" y="420000"/>
             <a:ext cx="11200000" cy="850000"/>
           </a:xfrm>
           <a:prstGeom prst="rect">
             <a:avLst/>
           </a:prstGeom>
           <a:solidFill>
-            <a:srgbClr val="07131D"/>
+            <a:srgbClr val="FFFFFF"/>
           </a:solidFill>
           <a:ln>
             <a:noFill/>
@@ -1216,10 +2400,10 @@
                 <a:rPr lang="en-US" sz="3000">
                   <a:b/>
                   <a:solidFill>
-                    <a:srgbClr val="41D7C3"/>
-                  </a:solidFill>
-                </a:rPr>
-                <a:t>Approach comparison</a:t>
+                    <a:srgbClr val="0000CC"/>
+                  </a:solidFill>
+                </a:rPr>
+                <a:t>NLP Model / Architecture Study</a:t>
               </a:r>
             </a:r>
             <a:endParaRPr lang="en-US" sz="3000"/>
@@ -1234,14 +2418,14 @@
         </p:nvSpPr>
         <p:spPr>
           <a:xfrm>
-            <a:off x="720000" y="1300000"/>
+            <a:off x="720000" y="1250000"/>
             <a:ext cx="11200000" cy="600000"/>
           </a:xfrm>
           <a:prstGeom prst="rect">
             <a:avLst/>
           </a:prstGeom>
           <a:solidFill>
-            <a:srgbClr val="07131D"/>
+            <a:srgbClr val="FFFFFF"/>
           </a:solidFill>
           <a:ln>
             <a:noFill/>
@@ -1256,10 +2440,10 @@
               <a:r>
                 <a:rPr lang="en-US" sz="1450">
                   <a:solidFill>
-                    <a:srgbClr val="8CA7B1"/>
-                  </a:solidFill>
-                </a:rPr>
-                <a:t>Rules are precise; context-aware learning recovers language entities</a:t>
+                    <a:srgbClr val="6B3E25"/>
+                  </a:solidFill>
+                </a:rPr>
+                <a:t>Transparent hybrid architecture</a:t>
               </a:r>
             </a:r>
             <a:endParaRPr lang="en-US" sz="1450"/>
@@ -1274,60 +2458,74 @@
         </p:nvSpPr>
         <p:spPr>
           <a:xfrm>
-            <a:off x="950000" y="2300000"/>
+            <a:off x="950000" y="2200000"/>
             <a:ext cx="10500000" cy="4300000"/>
           </a:xfrm>
           <a:prstGeom prst="rect">
             <a:avLst/>
           </a:prstGeom>
           <a:solidFill>
-            <a:srgbClr val="07131D"/>
-          </a:solidFill>
-          <a:ln>
-            <a:noFill/>
-          </a:ln>
-        </p:spPr>
-        <p:txBody>
-          <a:bodyPr wrap="square"/>
-          <a:lstStyle/>
-          <a:p>
-            <a:pPr marL="0" algn="l"/>
-            <a:r>
-              <a:r>
-                <a:rPr lang="en-US" sz="2100">
-                  <a:solidFill>
-                    <a:srgbClr val="EAF4F4"/>
-                  </a:solidFill>
-                </a:rPr>
-                <a:t>• Rules baseline: Precision 1.0000 · Recall 0.6255 · F1 0.7696</a:t>
-              </a:r>
-            </a:r>
-            <a:endParaRPr lang="en-US" sz="2100"/>
-          </a:p>
-          <a:p>
-            <a:pPr marL="0" algn="l"/>
-            <a:r>
-              <a:r>
-                <a:rPr lang="en-US" sz="2100">
-                  <a:solidFill>
-                    <a:srgbClr val="EAF4F4"/>
-                  </a:solidFill>
-                </a:rPr>
-                <a:t>• Averaged perceptron: Precision 0.9960 · Recall 0.9960 · F1 0.9960</a:t>
-              </a:r>
-            </a:r>
-            <a:endParaRPr lang="en-US" sz="2100"/>
-          </a:p>
-          <a:p>
-            <a:pPr marL="0" algn="l"/>
-            <a:r>
-              <a:r>
-                <a:rPr lang="en-US" sz="2100">
-                  <a:solidFill>
-                    <a:srgbClr val="EAF4F4"/>
-                  </a:solidFill>
-                </a:rPr>
-                <a:t>• Hybrid rules + model: Precision 0.9960 · Recall 0.9960 · F1 0.9960</a:t>
+            <a:srgbClr val="FFFFFF"/>
+          </a:solidFill>
+          <a:ln>
+            <a:noFill/>
+          </a:ln>
+        </p:spPr>
+        <p:txBody>
+          <a:bodyPr wrap="square"/>
+          <a:lstStyle/>
+          <a:p>
+            <a:pPr marL="0" algn="l"/>
+            <a:r>
+              <a:r>
+                <a:rPr lang="en-US" sz="2100">
+                  <a:solidFill>
+                    <a:srgbClr val="1A1A1A"/>
+                  </a:solidFill>
+                </a:rPr>
+                <a:t>• Tokenizer preserves character offsets and converts spans to BIO labels</a:t>
+              </a:r>
+            </a:r>
+            <a:endParaRPr lang="en-US" sz="2100"/>
+          </a:p>
+          <a:p>
+            <a:pPr marL="0" algn="l"/>
+            <a:r>
+              <a:r>
+                <a:rPr lang="en-US" sz="2100">
+                  <a:solidFill>
+                    <a:srgbClr val="1A1A1A"/>
+                  </a:solidFill>
+                </a:rPr>
+                <a:t>• Rules layer validates structured identifiers and applies Luhn verification to card-like values</a:t>
+              </a:r>
+            </a:r>
+            <a:endParaRPr lang="en-US" sz="2100"/>
+          </a:p>
+          <a:p>
+            <a:pPr marL="0" algn="l"/>
+            <a:r>
+              <a:r>
+                <a:rPr lang="en-US" sz="2100">
+                  <a:solidFill>
+                    <a:srgbClr val="1A1A1A"/>
+                  </a:solidFill>
+                </a:rPr>
+                <a:t>• Averaged perceptron uses token shape, context, prefixes, suffixes and previous BIO labels</a:t>
+              </a:r>
+            </a:r>
+            <a:endParaRPr lang="en-US" sz="2100"/>
+          </a:p>
+          <a:p>
+            <a:pPr marL="0" algn="l"/>
+            <a:r>
+              <a:r>
+                <a:rPr lang="en-US" sz="2100">
+                  <a:solidFill>
+                    <a:srgbClr val="1A1A1A"/>
+                  </a:solidFill>
+                </a:rPr>
+                <a:t>• Overlap resolution returns one auditable set of entities for redaction</a:t>
               </a:r>
             </a:r>
             <a:endParaRPr lang="en-US" sz="2100"/>
@@ -1349,7 +2547,7 @@
             <a:avLst/>
           </a:prstGeom>
           <a:solidFill>
-            <a:srgbClr val="07131D"/>
+            <a:srgbClr val="FFFFFF"/>
           </a:solidFill>
           <a:ln>
             <a:noFill/>
@@ -1364,10 +2562,10 @@
               <a:r>
                 <a:rPr lang="en-US" sz="900">
                   <a:solidFill>
-                    <a:srgbClr val="5C7A85"/>
-                  </a:solidFill>
-                </a:rPr>
-                <a:t>SentinelOS NLP activity  ·  6</a:t>
+                    <a:srgbClr val="6B3E25"/>
+                  </a:solidFill>
+                </a:rPr>
+                <a:t>Natural Language Processing for LLM · 24AM7PCLLM · 6</a:t>
               </a:r>
             </a:r>
             <a:endParaRPr lang="en-US" sz="900"/>
@@ -1407,14 +2605,14 @@
         </p:nvSpPr>
         <p:spPr>
           <a:xfrm>
-            <a:off x="720000" y="480000"/>
+            <a:off x="720000" y="420000"/>
             <a:ext cx="11200000" cy="850000"/>
           </a:xfrm>
           <a:prstGeom prst="rect">
             <a:avLst/>
           </a:prstGeom>
           <a:solidFill>
-            <a:srgbClr val="07131D"/>
+            <a:srgbClr val="FFFFFF"/>
           </a:solidFill>
           <a:ln>
             <a:noFill/>
@@ -1430,10 +2628,10 @@
                 <a:rPr lang="en-US" sz="3000">
                   <a:b/>
                   <a:solidFill>
-                    <a:srgbClr val="41D7C3"/>
-                  </a:solidFill>
-                </a:rPr>
-                <a:t>Example output</a:t>
+                    <a:srgbClr val="0000CC"/>
+                  </a:solidFill>
+                </a:rPr>
+                <a:t>Dataset and Preprocessing</a:t>
               </a:r>
             </a:r>
             <a:endParaRPr lang="en-US" sz="3000"/>
@@ -1448,14 +2646,14 @@
         </p:nvSpPr>
         <p:spPr>
           <a:xfrm>
-            <a:off x="720000" y="1300000"/>
+            <a:off x="720000" y="1250000"/>
             <a:ext cx="11200000" cy="600000"/>
           </a:xfrm>
           <a:prstGeom prst="rect">
             <a:avLst/>
           </a:prstGeom>
           <a:solidFill>
-            <a:srgbClr val="07131D"/>
+            <a:srgbClr val="FFFFFF"/>
           </a:solidFill>
           <a:ln>
             <a:noFill/>
@@ -1470,10 +2668,10 @@
               <a:r>
                 <a:rPr lang="en-US" sz="1450">
                   <a:solidFill>
-                    <a:srgbClr val="8CA7B1"/>
-                  </a:solidFill>
-                </a:rPr>
-                <a:t>The service protects downstream systems</a:t>
+                    <a:srgbClr val="6B3E25"/>
+                  </a:solidFill>
+                </a:rPr>
+                <a:t>Reproducible synthetic financial corpus</a:t>
               </a:r>
             </a:r>
             <a:endParaRPr lang="en-US" sz="1450"/>
@@ -1488,74 +2686,74 @@
         </p:nvSpPr>
         <p:spPr>
           <a:xfrm>
-            <a:off x="950000" y="2300000"/>
+            <a:off x="950000" y="2200000"/>
             <a:ext cx="10500000" cy="4300000"/>
           </a:xfrm>
           <a:prstGeom prst="rect">
             <a:avLst/>
           </a:prstGeom>
           <a:solidFill>
-            <a:srgbClr val="07131D"/>
-          </a:solidFill>
-          <a:ln>
-            <a:noFill/>
-          </a:ln>
-        </p:spPr>
-        <p:txBody>
-          <a:bodyPr wrap="square"/>
-          <a:lstStyle/>
-          <a:p>
-            <a:pPr marL="0" algn="l"/>
-            <a:r>
-              <a:r>
-                <a:rPr lang="en-US" sz="2100">
-                  <a:solidFill>
-                    <a:srgbClr val="EAF4F4"/>
-                  </a:solidFill>
-                </a:rPr>
-                <a:t>• Input: Maya Rao emailed maya.rao@example.com about card 4111 1111 1111 1111</a:t>
-              </a:r>
-            </a:r>
-            <a:endParaRPr lang="en-US" sz="2100"/>
-          </a:p>
-          <a:p>
-            <a:pPr marL="0" algn="l"/>
-            <a:r>
-              <a:r>
-                <a:rPr lang="en-US" sz="2100">
-                  <a:solidFill>
-                    <a:srgbClr val="EAF4F4"/>
-                  </a:solidFill>
-                </a:rPr>
-                <a:t>• Output: [PERSON] emailed [EMAIL] about card [CARD_NUMBER]</a:t>
-              </a:r>
-            </a:r>
-            <a:endParaRPr lang="en-US" sz="2100"/>
-          </a:p>
-          <a:p>
-            <a:pPr marL="0" algn="l"/>
-            <a:r>
-              <a:r>
-                <a:rPr lang="en-US" sz="2100">
-                  <a:solidFill>
-                    <a:srgbClr val="EAF4F4"/>
-                  </a:solidFill>
-                </a:rPr>
-                <a:t>• API: GET /health, GET /demo, POST /redact</a:t>
-              </a:r>
-            </a:r>
-            <a:endParaRPr lang="en-US" sz="2100"/>
-          </a:p>
-          <a:p>
-            <a:pPr marL="0" algn="l"/>
-            <a:r>
-              <a:r>
-                <a:rPr lang="en-US" sz="2100">
-                  <a:solidFill>
-                    <a:srgbClr val="EAF4F4"/>
-                  </a:solidFill>
-                </a:rPr>
-                <a:t>• The response contains masked metadata, not raw values for an LLM</a:t>
+            <a:srgbClr val="FFFFFF"/>
+          </a:solidFill>
+          <a:ln>
+            <a:noFill/>
+          </a:ln>
+        </p:spPr>
+        <p:txBody>
+          <a:bodyPr wrap="square"/>
+          <a:lstStyle/>
+          <a:p>
+            <a:pPr marL="0" algn="l"/>
+            <a:r>
+              <a:r>
+                <a:rPr lang="en-US" sz="2100">
+                  <a:solidFill>
+                    <a:srgbClr val="1A1A1A"/>
+                  </a:solidFill>
+                </a:rPr>
+                <a:t>• 600 examples from payment, KYC, refund, billing, support and privacy templates</a:t>
+              </a:r>
+            </a:r>
+            <a:endParaRPr lang="en-US" sz="2100"/>
+          </a:p>
+          <a:p>
+            <a:pPr marL="0" algn="l"/>
+            <a:r>
+              <a:r>
+                <a:rPr lang="en-US" sz="2100">
+                  <a:solidFill>
+                    <a:srgbClr val="1A1A1A"/>
+                  </a:solidFill>
+                </a:rPr>
+                <a:t>• Split: 420 train · 90 development · 90 test</a:t>
+              </a:r>
+            </a:r>
+            <a:endParaRPr lang="en-US" sz="2100"/>
+          </a:p>
+          <a:p>
+            <a:pPr marL="0" algn="l"/>
+            <a:r>
+              <a:r>
+                <a:rPr lang="en-US" sz="2100">
+                  <a:solidFill>
+                    <a:srgbClr val="1A1A1A"/>
+                  </a:solidFill>
+                </a:rPr>
+                <a:t>• Seed: 42; character-level spans; tokenization; BIO conversion</a:t>
+              </a:r>
+            </a:r>
+            <a:endParaRPr lang="en-US" sz="2100"/>
+          </a:p>
+          <a:p>
+            <a:pPr marL="0" algn="l"/>
+            <a:r>
+              <a:r>
+                <a:rPr lang="en-US" sz="2100">
+                  <a:solidFill>
+                    <a:srgbClr val="1A1A1A"/>
+                  </a:solidFill>
+                </a:rPr>
+                <a:t>• No real personal or payment data is used</a:t>
               </a:r>
             </a:r>
             <a:endParaRPr lang="en-US" sz="2100"/>
@@ -1577,7 +2775,7 @@
             <a:avLst/>
           </a:prstGeom>
           <a:solidFill>
-            <a:srgbClr val="07131D"/>
+            <a:srgbClr val="FFFFFF"/>
           </a:solidFill>
           <a:ln>
             <a:noFill/>
@@ -1592,10 +2790,10 @@
               <a:r>
                 <a:rPr lang="en-US" sz="900">
                   <a:solidFill>
-                    <a:srgbClr val="5C7A85"/>
-                  </a:solidFill>
-                </a:rPr>
-                <a:t>SentinelOS NLP activity  ·  7</a:t>
+                    <a:srgbClr val="6B3E25"/>
+                  </a:solidFill>
+                </a:rPr>
+                <a:t>Natural Language Processing for LLM · 24AM7PCLLM · 7</a:t>
               </a:r>
             </a:r>
             <a:endParaRPr lang="en-US" sz="900"/>
@@ -1635,14 +2833,14 @@
         </p:nvSpPr>
         <p:spPr>
           <a:xfrm>
-            <a:off x="720000" y="480000"/>
+            <a:off x="720000" y="420000"/>
             <a:ext cx="11200000" cy="850000"/>
           </a:xfrm>
           <a:prstGeom prst="rect">
             <a:avLst/>
           </a:prstGeom>
           <a:solidFill>
-            <a:srgbClr val="07131D"/>
+            <a:srgbClr val="FFFFFF"/>
           </a:solidFill>
           <a:ln>
             <a:noFill/>
@@ -1658,10 +2856,10 @@
                 <a:rPr lang="en-US" sz="3000">
                   <a:b/>
                   <a:solidFill>
-                    <a:srgbClr val="41D7C3"/>
-                  </a:solidFill>
-                </a:rPr>
-                <a:t>Conclusion</a:t>
+                    <a:srgbClr val="0000CC"/>
+                  </a:solidFill>
+                </a:rPr>
+                <a:t>Implementation Methodology</a:t>
               </a:r>
             </a:r>
             <a:endParaRPr lang="en-US" sz="3000"/>
@@ -1676,14 +2874,14 @@
         </p:nvSpPr>
         <p:spPr>
           <a:xfrm>
-            <a:off x="720000" y="1300000"/>
+            <a:off x="720000" y="1250000"/>
             <a:ext cx="11200000" cy="600000"/>
           </a:xfrm>
           <a:prstGeom prst="rect">
             <a:avLst/>
           </a:prstGeom>
           <a:solidFill>
-            <a:srgbClr val="07131D"/>
+            <a:srgbClr val="FFFFFF"/>
           </a:solidFill>
           <a:ln>
             <a:noFill/>
@@ -1698,10 +2896,10 @@
               <a:r>
                 <a:rPr lang="en-US" sz="1450">
                   <a:solidFill>
-                    <a:srgbClr val="8CA7B1"/>
-                  </a:solidFill>
-                </a:rPr>
-                <a:t>A practical, privacy-first NER contribution</a:t>
+                    <a:srgbClr val="6B3E25"/>
+                  </a:solidFill>
+                </a:rPr>
+                <a:t>From corpus generation to API response</a:t>
               </a:r>
             </a:r>
             <a:endParaRPr lang="en-US" sz="1450"/>
@@ -1716,60 +2914,88 @@
         </p:nvSpPr>
         <p:spPr>
           <a:xfrm>
-            <a:off x="950000" y="2300000"/>
+            <a:off x="950000" y="2200000"/>
             <a:ext cx="10500000" cy="4300000"/>
           </a:xfrm>
           <a:prstGeom prst="rect">
             <a:avLst/>
           </a:prstGeom>
           <a:solidFill>
-            <a:srgbClr val="07131D"/>
-          </a:solidFill>
-          <a:ln>
-            <a:noFill/>
-          </a:ln>
-        </p:spPr>
-        <p:txBody>
-          <a:bodyPr wrap="square"/>
-          <a:lstStyle/>
-          <a:p>
-            <a:pPr marL="0" algn="l"/>
-            <a:r>
-              <a:r>
-                <a:rPr lang="en-US" sz="2100">
-                  <a:solidFill>
-                    <a:srgbClr val="EAF4F4"/>
-                  </a:solidFill>
-                </a:rPr>
-                <a:t>• The hybrid architecture combines explicit validation with contextual language understanding</a:t>
-              </a:r>
-            </a:r>
-            <a:endParaRPr lang="en-US" sz="2100"/>
-          </a:p>
-          <a:p>
-            <a:pPr marL="0" algn="l"/>
-            <a:r>
-              <a:r>
-                <a:rPr lang="en-US" sz="2100">
-                  <a:solidFill>
-                    <a:srgbClr val="EAF4F4"/>
-                  </a:solidFill>
-                </a:rPr>
-                <a:t>• The synthetic benchmark is a controlled classroom experiment, not a production guarantee</a:t>
-              </a:r>
-            </a:r>
-            <a:endParaRPr lang="en-US" sz="2100"/>
-          </a:p>
-          <a:p>
-            <a:pPr marL="0" algn="l"/>
-            <a:r>
-              <a:r>
-                <a:rPr lang="en-US" sz="2100">
-                  <a:solidFill>
-                    <a:srgbClr val="EAF4F4"/>
-                  </a:solidFill>
-                </a:rPr>
-                <a:t>• Next: held-out templates, human annotation, transformer comparison, calibration and SentinelOS integration</a:t>
+            <a:srgbClr val="FFFFFF"/>
+          </a:solidFill>
+          <a:ln>
+            <a:noFill/>
+          </a:ln>
+        </p:spPr>
+        <p:txBody>
+          <a:bodyPr wrap="square"/>
+          <a:lstStyle/>
+          <a:p>
+            <a:pPr marL="0" algn="l"/>
+            <a:r>
+              <a:r>
+                <a:rPr lang="en-US" sz="2100">
+                  <a:solidFill>
+                    <a:srgbClr val="1A1A1A"/>
+                  </a:solidFill>
+                </a:rPr>
+                <a:t>• Generate synthetic examples and gold entity spans</a:t>
+              </a:r>
+            </a:r>
+            <a:endParaRPr lang="en-US" sz="2100"/>
+          </a:p>
+          <a:p>
+            <a:pPr marL="0" algn="l"/>
+            <a:r>
+              <a:r>
+                <a:rPr lang="en-US" sz="2100">
+                  <a:solidFill>
+                    <a:srgbClr val="1A1A1A"/>
+                  </a:solidFill>
+                </a:rPr>
+                <a:t>• Train the averaged perceptron for eight epochs</a:t>
+              </a:r>
+            </a:r>
+            <a:endParaRPr lang="en-US" sz="2100"/>
+          </a:p>
+          <a:p>
+            <a:pPr marL="0" algn="l"/>
+            <a:r>
+              <a:r>
+                <a:rPr lang="en-US" sz="2100">
+                  <a:solidFill>
+                    <a:srgbClr val="1A1A1A"/>
+                  </a:solidFill>
+                </a:rPr>
+                <a:t>• Run rules, model and hybrid approaches on the held-out test split</a:t>
+              </a:r>
+            </a:r>
+            <a:endParaRPr lang="en-US" sz="2100"/>
+          </a:p>
+          <a:p>
+            <a:pPr marL="0" algn="l"/>
+            <a:r>
+              <a:r>
+                <a:rPr lang="en-US" sz="2100">
+                  <a:solidFill>
+                    <a:srgbClr val="1A1A1A"/>
+                  </a:solidFill>
+                </a:rPr>
+                <a:t>• Serialize metrics, sample predictions and dataset JSONL</a:t>
+              </a:r>
+            </a:r>
+            <a:endParaRPr lang="en-US" sz="2100"/>
+          </a:p>
+          <a:p>
+            <a:pPr marL="0" algn="l"/>
+            <a:r>
+              <a:r>
+                <a:rPr lang="en-US" sz="2100">
+                  <a:solidFill>
+                    <a:srgbClr val="1A1A1A"/>
+                  </a:solidFill>
+                </a:rPr>
+                <a:t>• Expose the detector through a dependency-free local JSON API</a:t>
               </a:r>
             </a:r>
             <a:endParaRPr lang="en-US" sz="2100"/>
@@ -1791,7 +3017,7 @@
             <a:avLst/>
           </a:prstGeom>
           <a:solidFill>
-            <a:srgbClr val="07131D"/>
+            <a:srgbClr val="FFFFFF"/>
           </a:solidFill>
           <a:ln>
             <a:noFill/>
@@ -1806,10 +3032,224 @@
               <a:r>
                 <a:rPr lang="en-US" sz="900">
                   <a:solidFill>
-                    <a:srgbClr val="5C7A85"/>
-                  </a:solidFill>
-                </a:rPr>
-                <a:t>SentinelOS NLP activity  ·  8</a:t>
+                    <a:srgbClr val="6B3E25"/>
+                  </a:solidFill>
+                </a:rPr>
+                <a:t>Natural Language Processing for LLM · 24AM7PCLLM · 8</a:t>
+              </a:r>
+            </a:r>
+            <a:endParaRPr lang="en-US" sz="900"/>
+          </a:p>
+        </p:txBody>
+      </p:sp>
+    </p:spTree>
+  </p:cSld>
+  <p:clrMapOvr>
+    <a:masterClrMapping/>
+  </p:clrMapOvr>
+</p:sld>
+</file>
+
+<file path=ppt/slides/slide9.xml><?xml version="1.0" encoding="utf-8"?>
+<p:sld xmlns:a="http://schemas.openxmlformats.org/drawingml/2006/main" xmlns:r="http://schemas.openxmlformats.org/officeDocument/2006/relationships" xmlns:p="http://schemas.openxmlformats.org/presentationml/2006/main">
+  <p:cSld>
+    <p:spTree>
+      <p:nvGrpSpPr>
+        <p:cNvPr id="1" name=""/>
+        <p:cNvGrpSpPr/>
+        <p:nvPr/>
+      </p:nvGrpSpPr>
+      <p:grpSpPr>
+        <a:xfrm>
+          <a:off x="0" y="0"/>
+          <a:ext cx="0" cy="0"/>
+          <a:chOff x="0" y="0"/>
+          <a:chExt cx="0" cy="0"/>
+        </a:xfrm>
+      </p:grpSpPr>
+      <p:sp>
+        <p:nvSpPr>
+          <p:cNvPr id="2" name="TextBox 2"/>
+          <p:cNvSpPr/>
+          <p:nvPr/>
+        </p:nvSpPr>
+        <p:spPr>
+          <a:xfrm>
+            <a:off x="720000" y="420000"/>
+            <a:ext cx="11200000" cy="850000"/>
+          </a:xfrm>
+          <a:prstGeom prst="rect">
+            <a:avLst/>
+          </a:prstGeom>
+          <a:solidFill>
+            <a:srgbClr val="FFFFFF"/>
+          </a:solidFill>
+          <a:ln>
+            <a:noFill/>
+          </a:ln>
+        </p:spPr>
+        <p:txBody>
+          <a:bodyPr wrap="square"/>
+          <a:lstStyle/>
+          <a:p>
+            <a:pPr marL="0" algn="l"/>
+            <a:r>
+              <a:r>
+                <a:rPr lang="en-US" sz="3000">
+                  <a:b/>
+                  <a:solidFill>
+                    <a:srgbClr val="0000CC"/>
+                  </a:solidFill>
+                </a:rPr>
+                <a:t>Results and Evaluation</a:t>
+              </a:r>
+            </a:r>
+            <a:endParaRPr lang="en-US" sz="3000"/>
+          </a:p>
+        </p:txBody>
+      </p:sp>
+      <p:sp>
+        <p:nvSpPr>
+          <p:cNvPr id="3" name="TextBox 3"/>
+          <p:cNvSpPr/>
+          <p:nvPr/>
+        </p:nvSpPr>
+        <p:spPr>
+          <a:xfrm>
+            <a:off x="720000" y="1250000"/>
+            <a:ext cx="11200000" cy="600000"/>
+          </a:xfrm>
+          <a:prstGeom prst="rect">
+            <a:avLst/>
+          </a:prstGeom>
+          <a:solidFill>
+            <a:srgbClr val="FFFFFF"/>
+          </a:solidFill>
+          <a:ln>
+            <a:noFill/>
+          </a:ln>
+        </p:spPr>
+        <p:txBody>
+          <a:bodyPr wrap="square"/>
+          <a:lstStyle/>
+          <a:p>
+            <a:pPr marL="0" algn="l"/>
+            <a:r>
+              <a:r>
+                <a:rPr lang="en-US" sz="1450">
+                  <a:solidFill>
+                    <a:srgbClr val="6B3E25"/>
+                  </a:solidFill>
+                </a:rPr>
+                <a:t>Exact entity-level comparison</a:t>
+              </a:r>
+            </a:r>
+            <a:endParaRPr lang="en-US" sz="1450"/>
+          </a:p>
+        </p:txBody>
+      </p:sp>
+      <p:sp>
+        <p:nvSpPr>
+          <p:cNvPr id="4" name="TextBox 4"/>
+          <p:cNvSpPr/>
+          <p:nvPr/>
+        </p:nvSpPr>
+        <p:spPr>
+          <a:xfrm>
+            <a:off x="950000" y="2200000"/>
+            <a:ext cx="10500000" cy="4300000"/>
+          </a:xfrm>
+          <a:prstGeom prst="rect">
+            <a:avLst/>
+          </a:prstGeom>
+          <a:solidFill>
+            <a:srgbClr val="FFFFFF"/>
+          </a:solidFill>
+          <a:ln>
+            <a:noFill/>
+          </a:ln>
+        </p:spPr>
+        <p:txBody>
+          <a:bodyPr wrap="square"/>
+          <a:lstStyle/>
+          <a:p>
+            <a:pPr marL="0" algn="l"/>
+            <a:r>
+              <a:r>
+                <a:rPr lang="en-US" sz="2100">
+                  <a:solidFill>
+                    <a:srgbClr val="1A1A1A"/>
+                  </a:solidFill>
+                </a:rPr>
+                <a:t>• Rules baseline: Precision 1.0000 · Recall 0.6255 · F1 0.7696</a:t>
+              </a:r>
+            </a:r>
+            <a:endParaRPr lang="en-US" sz="2100"/>
+          </a:p>
+          <a:p>
+            <a:pPr marL="0" algn="l"/>
+            <a:r>
+              <a:r>
+                <a:rPr lang="en-US" sz="2100">
+                  <a:solidFill>
+                    <a:srgbClr val="1A1A1A"/>
+                  </a:solidFill>
+                </a:rPr>
+                <a:t>• Averaged perceptron: Precision 0.9960 · Recall 0.9960 · F1 0.9960</a:t>
+              </a:r>
+            </a:r>
+            <a:endParaRPr lang="en-US" sz="2100"/>
+          </a:p>
+          <a:p>
+            <a:pPr marL="0" algn="l"/>
+            <a:r>
+              <a:r>
+                <a:rPr lang="en-US" sz="2100">
+                  <a:solidFill>
+                    <a:srgbClr val="1A1A1A"/>
+                  </a:solidFill>
+                </a:rPr>
+                <a:t>• Hybrid rules + model: Precision 0.9960 · Recall 0.9960 · F1 0.9960</a:t>
+              </a:r>
+            </a:r>
+            <a:endParaRPr lang="en-US" sz="2100"/>
+          </a:p>
+        </p:txBody>
+      </p:sp>
+      <p:sp>
+        <p:nvSpPr>
+          <p:cNvPr id="5" name="TextBox 5"/>
+          <p:cNvSpPr/>
+          <p:nvPr/>
+        </p:nvSpPr>
+        <p:spPr>
+          <a:xfrm>
+            <a:off x="720000" y="6900000"/>
+            <a:ext cx="11200000" cy="250000"/>
+          </a:xfrm>
+          <a:prstGeom prst="rect">
+            <a:avLst/>
+          </a:prstGeom>
+          <a:solidFill>
+            <a:srgbClr val="FFFFFF"/>
+          </a:solidFill>
+          <a:ln>
+            <a:noFill/>
+          </a:ln>
+        </p:spPr>
+        <p:txBody>
+          <a:bodyPr wrap="square"/>
+          <a:lstStyle/>
+          <a:p>
+            <a:pPr marL="0" algn="l"/>
+            <a:r>
+              <a:r>
+                <a:rPr lang="en-US" sz="900">
+                  <a:solidFill>
+                    <a:srgbClr val="6B3E25"/>
+                  </a:solidFill>
+                </a:rPr>
+                <a:t>Natural Language Processing for LLM · 24AM7PCLLM · 9</a:t>
               </a:r>
             </a:r>
             <a:endParaRPr lang="en-US" sz="900"/>

</xml_diff>